<commit_message>
Angry Birds deck: same essentials, different form
The physics library as step-read-draw, metres vs. pixels as a problem,
Adapter and Facade as layers between the game and Box2D, the two worlds
as entity and body, and the whole game as a flow; old text in the
speaker notes and the site's Check yourself questions at the end.

Co-Authored-By: Claude Opus 5.5 <noreply@anthropic.com>
Claude-Session: https://claude.ai/code/session_012sjsUQBbC7zon57rWHoo9d
</commit_message>
<xml_diff>
--- a/slides/07 Angry Birds.pptx
+++ b/slides/07 Angry Birds.pptx
@@ -31,6 +31,7 @@
     <p:sldId id="280" r:id="rId30"/>
     <p:sldId id="292" r:id="rId42"/>
     <p:sldId id="293" r:id="rId52"/>
+    <p:sldId id="313" r:id="rId40"/>
     <p:sldId id="294" r:id="rId53"/>
     <p:sldId id="296" r:id="rId55"/>
   </p:sldIdLst>
@@ -829,6 +830,245 @@
 </p:notes>
 </file>
 
+<file path=ppt/notesSlides/notesSlide10.xml><?xml version="1.0" encoding="utf-8"?>
+<p:notes xmlns:a="http://schemas.openxmlformats.org/drawingml/2006/main" xmlns:p="http://schemas.openxmlformats.org/presentationml/2006/main" xmlns:r="http://schemas.openxmlformats.org/officeDocument/2006/relationships">
+  <p:cSld>
+    <p:spTree>
+      <p:nvGrpSpPr>
+        <p:cNvPr id="1" name=""/>
+        <p:cNvGrpSpPr/>
+        <p:nvPr/>
+      </p:nvGrpSpPr>
+      <p:grpSpPr>
+        <a:xfrm>
+          <a:off x="0" y="0"/>
+          <a:ext cx="0" cy="0"/>
+          <a:chOff x="0" y="0"/>
+          <a:chExt cx="0" cy="0"/>
+        </a:xfrm>
+      </p:grpSpPr>
+      <p:sp>
+        <p:nvSpPr>
+          <p:cNvPr id="2" name="Slide Image Placeholder 1"/>
+          <p:cNvSpPr>
+            <a:spLocks noGrp="1"/>
+          </p:cNvSpPr>
+          <p:nvPr>
+            <p:ph type="sldImg" idx="2"/>
+          </p:nvPr>
+        </p:nvSpPr>
+        <p:spPr/>
+      </p:sp>
+      <p:sp>
+        <p:nvSpPr>
+          <p:cNvPr id="3" name="Notes Placeholder 2"/>
+          <p:cNvSpPr>
+            <a:spLocks noGrp="1"/>
+          </p:cNvSpPr>
+          <p:nvPr>
+            <p:ph type="body" idx="1"/>
+          </p:nvPr>
+        </p:nvSpPr>
+        <p:spPr/>
+        <p:txBody>
+          <a:bodyPr/>
+          <a:lstStyle/>
+          <a:p>
+            <a:r>
+              <a:t>Talking points:</a:t>
+            </a:r>
+          </a:p>
+          <a:p>
+            <a:r>
+              <a:t>- A block exists twice: an entity, and a body</a:t>
+            </a:r>
+          </a:p>
+          <a:p>
+            <a:r>
+              <a:t>- The physics world owns the position</a:t>
+            </a:r>
+          </a:p>
+          <a:p>
+            <a:r>
+              <a:t>  - An entity reads its body’s position every time it’s drawn</a:t>
+            </a:r>
+          </a:p>
+          <a:p>
+            <a:r>
+              <a:t>- And the body knows its owner</a:t>
+            </a:r>
+          </a:p>
+          <a:p>
+            <a:r>
+              <a:t>  - So events about bodies lead back to entities</a:t>
+            </a:r>
+          </a:p>
+          <a:p>
+            <a:r>
+              <a:t>- F1: what the physics world sees (awake green, asleep blue)</a:t>
+            </a:r>
+          </a:p>
+          <a:p>
+            <a:r>
+              <a:t>- A fixed time step: Snake’s accumulator, again</a:t>
+            </a:r>
+          </a:p>
+        </p:txBody>
+      </p:sp>
+    </p:spTree>
+  </p:cSld>
+  <p:clrMapOvr>
+    <a:masterClrMapping/>
+  </p:clrMapOvr>
+</p:notes>
+</file>
+
+<file path=ppt/notesSlides/notesSlide11.xml><?xml version="1.0" encoding="utf-8"?>
+<p:notes xmlns:a="http://schemas.openxmlformats.org/drawingml/2006/main" xmlns:p="http://schemas.openxmlformats.org/presentationml/2006/main" xmlns:r="http://schemas.openxmlformats.org/officeDocument/2006/relationships">
+  <p:cSld>
+    <p:spTree>
+      <p:nvGrpSpPr>
+        <p:cNvPr id="1" name=""/>
+        <p:cNvGrpSpPr/>
+        <p:nvPr/>
+      </p:nvGrpSpPr>
+      <p:grpSpPr>
+        <a:xfrm>
+          <a:off x="0" y="0"/>
+          <a:ext cx="0" cy="0"/>
+          <a:chOff x="0" y="0"/>
+          <a:chExt cx="0" cy="0"/>
+        </a:xfrm>
+      </p:grpSpPr>
+      <p:sp>
+        <p:nvSpPr>
+          <p:cNvPr id="2" name="Slide Image Placeholder 1"/>
+          <p:cNvSpPr>
+            <a:spLocks noGrp="1"/>
+          </p:cNvSpPr>
+          <p:nvPr>
+            <p:ph type="sldImg" idx="2"/>
+          </p:nvPr>
+        </p:nvSpPr>
+        <p:spPr/>
+      </p:sp>
+      <p:sp>
+        <p:nvSpPr>
+          <p:cNvPr id="3" name="Notes Placeholder 2"/>
+          <p:cNvSpPr>
+            <a:spLocks noGrp="1"/>
+          </p:cNvSpPr>
+          <p:nvPr>
+            <p:ph type="body" idx="1"/>
+          </p:nvPr>
+        </p:nvSpPr>
+        <p:spPr/>
+        <p:txBody>
+          <a:bodyPr/>
+          <a:lstStyle/>
+          <a:p>
+            <a:r>
+              <a:t>Talking points:</a:t>
+            </a:r>
+          </a:p>
+          <a:p>
+            <a:r>
+              <a:t>- Three levels, a few birds each</a:t>
+            </a:r>
+          </a:p>
+          <a:p>
+            <a:r>
+              <a:t>- Game states: Aim → Fly → Aim or Level End</a:t>
+            </a:r>
+          </a:p>
+          <a:p>
+            <a:r>
+              <a:t>- Fly waits until the world has settled</a:t>
+            </a:r>
+          </a:p>
+          <a:p>
+            <a:r>
+              <a:t>  - The facade answers it in one line: IsSettled</a:t>
+            </a:r>
+          </a:p>
+          <a:p>
+            <a:r>
+              <a:t>- The aiming curve doesn’t use the physics world</a:t>
+            </a:r>
+          </a:p>
+          <a:p>
+            <a:r>
+              <a:t>  - start + velocity × t + gravity × t² / 2</a:t>
+            </a:r>
+          </a:p>
+        </p:txBody>
+      </p:sp>
+    </p:spTree>
+  </p:cSld>
+  <p:clrMapOvr>
+    <a:masterClrMapping/>
+  </p:clrMapOvr>
+</p:notes>
+</file>
+
+<file path=ppt/notesSlides/notesSlide12.xml><?xml version="1.0" encoding="utf-8"?>
+<p:notes xmlns:a="http://schemas.openxmlformats.org/drawingml/2006/main" xmlns:p="http://schemas.openxmlformats.org/presentationml/2006/main" xmlns:r="http://schemas.openxmlformats.org/officeDocument/2006/relationships">
+  <p:cSld>
+    <p:spTree>
+      <p:nvGrpSpPr>
+        <p:cNvPr id="1" name=""/>
+        <p:cNvGrpSpPr/>
+        <p:nvPr/>
+      </p:nvGrpSpPr>
+      <p:grpSpPr>
+        <a:xfrm>
+          <a:off x="0" y="0"/>
+          <a:ext cx="0" cy="0"/>
+          <a:chOff x="0" y="0"/>
+          <a:chExt cx="0" cy="0"/>
+        </a:xfrm>
+      </p:grpSpPr>
+      <p:sp>
+        <p:nvSpPr>
+          <p:cNvPr id="2" name="Slide Image Placeholder 1"/>
+          <p:cNvSpPr>
+            <a:spLocks noGrp="1"/>
+          </p:cNvSpPr>
+          <p:nvPr>
+            <p:ph type="sldImg" idx="2"/>
+          </p:nvPr>
+        </p:nvSpPr>
+        <p:spPr/>
+      </p:sp>
+      <p:sp>
+        <p:nvSpPr>
+          <p:cNvPr id="3" name="Notes Placeholder 2"/>
+          <p:cNvSpPr>
+            <a:spLocks noGrp="1"/>
+          </p:cNvSpPr>
+          <p:nvPr>
+            <p:ph type="body" idx="1"/>
+          </p:nvPr>
+        </p:nvSpPr>
+        <p:spPr/>
+        <p:txBody>
+          <a:bodyPr/>
+          <a:lstStyle/>
+          <a:p>
+            <a:r>
+              <a:t>Ask, let them answer in pairs for a minute, then take a few answers. These are the site’s Check yourself questions.</a:t>
+            </a:r>
+          </a:p>
+        </p:txBody>
+      </p:sp>
+    </p:spTree>
+  </p:cSld>
+  <p:clrMapOvr>
+    <a:masterClrMapping/>
+  </p:clrMapOvr>
+</p:notes>
+</file>
+
 <file path=ppt/notesSlides/notesSlide2.xml><?xml version="1.0" encoding="utf-8"?>
 <p:notes xmlns:a="http://schemas.openxmlformats.org/drawingml/2006/main" xmlns:r="http://schemas.openxmlformats.org/officeDocument/2006/relationships" xmlns:mc="http://schemas.openxmlformats.org/markup-compatibility/2006" xmlns:mv="urn:schemas-microsoft-com:mac:vml" xmlns:p="http://schemas.openxmlformats.org/presentationml/2006/main" xmlns:c="http://schemas.openxmlformats.org/drawingml/2006/chart" xmlns:dgm="http://schemas.openxmlformats.org/drawingml/2006/diagram" xmlns:o="urn:schemas-microsoft-com:office:office" xmlns:v="urn:schemas-microsoft-com:vml" xmlns:pvml="urn:schemas-microsoft-com:office:powerpoint" xmlns:com="http://schemas.openxmlformats.org/drawingml/2006/compatibility" xmlns:p14="http://schemas.microsoft.com/office/powerpoint/2010/main" xmlns:p15="http://schemas.microsoft.com/office/powerpoint/2012/main" xmlns:ahyp="http://schemas.microsoft.com/office/drawing/2018/hyperlinkcolor" showMasterPhAnim="0" showMasterSp="0">
   <p:cSld>
@@ -1300,19 +1540,308 @@
           </a:bodyPr>
           <a:lstStyle/>
           <a:p>
-            <a:pPr indent="0" lvl="0" marL="0" rtl="0" algn="l">
-              <a:spcBef>
-                <a:spcPts val="0"/>
-              </a:spcBef>
-              <a:spcAft>
-                <a:spcPts val="0"/>
-              </a:spcAft>
-              <a:buNone/>
-            </a:pPr>
-            <a:r>
-              <a:t/>
-            </a:r>
-            <a:endParaRPr/>
+            <a:r>
+              <a:t>Talking points:</a:t>
+            </a:r>
+          </a:p>
+          <a:p>
+            <a:r>
+              <a:t>- All Source code for today’s game can be found here:</a:t>
+            </a:r>
+          </a:p>
+          <a:p>
+            <a:r>
+              <a:t>  - github.com/Metamate/gar-games (folder 07-angry-birds)</a:t>
+            </a:r>
+          </a:p>
+          <a:p>
+            <a:r>
+              <a:t>- The game is built up in steps: Birds0 → Birds4</a:t>
+            </a:r>
+          </a:p>
+          <a:p>
+            <a:r>
+              <a:t>  - Each step is a separate project that adds one concept</a:t>
+            </a:r>
+          </a:p>
+          <a:p>
+            <a:r>
+              <a:t>  - Compare neighbouring steps to see exactly what changed</a:t>
+            </a:r>
+          </a:p>
+          <a:p>
+            <a:r>
+              <a:t>- Birds4 is the finished game, and the starting point for the exercises</a:t>
+            </a:r>
+          </a:p>
+        </p:txBody>
+      </p:sp>
+    </p:spTree>
+  </p:cSld>
+  <p:clrMapOvr>
+    <a:masterClrMapping/>
+  </p:clrMapOvr>
+</p:notes>
+</file>
+
+<file path=ppt/notesSlides/notesSlide7.xml><?xml version="1.0" encoding="utf-8"?>
+<p:notes xmlns:a="http://schemas.openxmlformats.org/drawingml/2006/main" xmlns:p="http://schemas.openxmlformats.org/presentationml/2006/main" xmlns:r="http://schemas.openxmlformats.org/officeDocument/2006/relationships">
+  <p:cSld>
+    <p:spTree>
+      <p:nvGrpSpPr>
+        <p:cNvPr id="1" name=""/>
+        <p:cNvGrpSpPr/>
+        <p:nvPr/>
+      </p:nvGrpSpPr>
+      <p:grpSpPr>
+        <a:xfrm>
+          <a:off x="0" y="0"/>
+          <a:ext cx="0" cy="0"/>
+          <a:chOff x="0" y="0"/>
+          <a:chExt cx="0" cy="0"/>
+        </a:xfrm>
+      </p:grpSpPr>
+      <p:sp>
+        <p:nvSpPr>
+          <p:cNvPr id="2" name="Slide Image Placeholder 1"/>
+          <p:cNvSpPr>
+            <a:spLocks noGrp="1"/>
+          </p:cNvSpPr>
+          <p:nvPr>
+            <p:ph type="sldImg" idx="2"/>
+          </p:nvPr>
+        </p:nvSpPr>
+        <p:spPr/>
+      </p:sp>
+      <p:sp>
+        <p:nvSpPr>
+          <p:cNvPr id="3" name="Notes Placeholder 2"/>
+          <p:cNvSpPr>
+            <a:spLocks noGrp="1"/>
+          </p:cNvSpPr>
+          <p:nvPr>
+            <p:ph type="body" idx="1"/>
+          </p:nvPr>
+        </p:nvSpPr>
+        <p:spPr/>
+        <p:txBody>
+          <a:bodyPr/>
+          <a:lstStyle/>
+          <a:p>
+            <a:r>
+              <a:t>Talking points:</a:t>
+            </a:r>
+          </a:p>
+          <a:p>
+            <a:r>
+              <a:t>- Stacks that tip, bounce and break: more than Mario’s physics</a:t>
+            </a:r>
+          </a:p>
+          <a:p>
+            <a:r>
+              <a:t>- Box2D: a 2D physics engine, used in many games</a:t>
+            </a:r>
+          </a:p>
+          <a:p>
+            <a:r>
+              <a:t>  - Box2D.NET: a C# port, added as a NuGet package</a:t>
+            </a:r>
+          </a:p>
+          <a:p>
+            <a:r>
+              <a:t>- A world of bodies</a:t>
+            </a:r>
+          </a:p>
+          <a:p>
+            <a:r>
+              <a:t>  - Each body has shapes: boxes, circles, polygons</a:t>
+            </a:r>
+          </a:p>
+          <a:p>
+            <a:r>
+              <a:t>  - Static bodies never move; dynamic bodies are moved by gravity and collisions</a:t>
+            </a:r>
+          </a:p>
+          <a:p>
+            <a:r>
+              <a:t>- Step the world forward, then read where the bodies are</a:t>
+            </a:r>
+          </a:p>
+        </p:txBody>
+      </p:sp>
+    </p:spTree>
+  </p:cSld>
+  <p:clrMapOvr>
+    <a:masterClrMapping/>
+  </p:clrMapOvr>
+</p:notes>
+</file>
+
+<file path=ppt/notesSlides/notesSlide8.xml><?xml version="1.0" encoding="utf-8"?>
+<p:notes xmlns:a="http://schemas.openxmlformats.org/drawingml/2006/main" xmlns:p="http://schemas.openxmlformats.org/presentationml/2006/main" xmlns:r="http://schemas.openxmlformats.org/officeDocument/2006/relationships">
+  <p:cSld>
+    <p:spTree>
+      <p:nvGrpSpPr>
+        <p:cNvPr id="1" name=""/>
+        <p:cNvGrpSpPr/>
+        <p:nvPr/>
+      </p:nvGrpSpPr>
+      <p:grpSpPr>
+        <a:xfrm>
+          <a:off x="0" y="0"/>
+          <a:ext cx="0" cy="0"/>
+          <a:chOff x="0" y="0"/>
+          <a:chExt cx="0" cy="0"/>
+        </a:xfrm>
+      </p:grpSpPr>
+      <p:sp>
+        <p:nvSpPr>
+          <p:cNvPr id="2" name="Slide Image Placeholder 1"/>
+          <p:cNvSpPr>
+            <a:spLocks noGrp="1"/>
+          </p:cNvSpPr>
+          <p:nvPr>
+            <p:ph type="sldImg" idx="2"/>
+          </p:nvPr>
+        </p:nvSpPr>
+        <p:spPr/>
+      </p:sp>
+      <p:sp>
+        <p:nvSpPr>
+          <p:cNvPr id="3" name="Notes Placeholder 2"/>
+          <p:cNvSpPr>
+            <a:spLocks noGrp="1"/>
+          </p:cNvSpPr>
+          <p:nvPr>
+            <p:ph type="body" idx="1"/>
+          </p:nvPr>
+        </p:nvSpPr>
+        <p:spPr/>
+        <p:txBody>
+          <a:bodyPr/>
+          <a:lstStyle/>
+          <a:p>
+            <a:r>
+              <a:t>Talking points:</a:t>
+            </a:r>
+          </a:p>
+          <a:p>
+            <a:r>
+              <a:t>- Box2D is tuned for objects of 0.1 to 10 metres</a:t>
+            </a:r>
+          </a:p>
+          <a:p>
+            <a:r>
+              <a:t>  - A 50-pixel block would be a 50-metre block</a:t>
+            </a:r>
+          </a:p>
+          <a:p>
+            <a:r>
+              <a:t>  - It would fall as slowly as a building</a:t>
+            </a:r>
+          </a:p>
+          <a:p>
+            <a:r>
+              <a:t>- Simulate in metres, draw in pixels: 50 pixels per metre</a:t>
+            </a:r>
+          </a:p>
+          <a:p>
+            <a:r>
+              <a:t>- Box2D turns counter-clockwise, SpriteBatch clockwise</a:t>
+            </a:r>
+          </a:p>
+          <a:p>
+            <a:r>
+              <a:t>- Forget one conversion: a body in the wrong place, or falling up</a:t>
+            </a:r>
+          </a:p>
+        </p:txBody>
+      </p:sp>
+    </p:spTree>
+  </p:cSld>
+  <p:clrMapOvr>
+    <a:masterClrMapping/>
+  </p:clrMapOvr>
+</p:notes>
+</file>
+
+<file path=ppt/notesSlides/notesSlide9.xml><?xml version="1.0" encoding="utf-8"?>
+<p:notes xmlns:a="http://schemas.openxmlformats.org/drawingml/2006/main" xmlns:p="http://schemas.openxmlformats.org/presentationml/2006/main" xmlns:r="http://schemas.openxmlformats.org/officeDocument/2006/relationships">
+  <p:cSld>
+    <p:spTree>
+      <p:nvGrpSpPr>
+        <p:cNvPr id="1" name=""/>
+        <p:cNvGrpSpPr/>
+        <p:nvPr/>
+      </p:nvGrpSpPr>
+      <p:grpSpPr>
+        <a:xfrm>
+          <a:off x="0" y="0"/>
+          <a:ext cx="0" cy="0"/>
+          <a:chOff x="0" y="0"/>
+          <a:chExt cx="0" cy="0"/>
+        </a:xfrm>
+      </p:grpSpPr>
+      <p:sp>
+        <p:nvSpPr>
+          <p:cNvPr id="2" name="Slide Image Placeholder 1"/>
+          <p:cNvSpPr>
+            <a:spLocks noGrp="1"/>
+          </p:cNvSpPr>
+          <p:nvPr>
+            <p:ph type="sldImg" idx="2"/>
+          </p:nvPr>
+        </p:nvSpPr>
+        <p:spPr/>
+      </p:sp>
+      <p:sp>
+        <p:nvSpPr>
+          <p:cNvPr id="3" name="Notes Placeholder 2"/>
+          <p:cNvSpPr>
+            <a:spLocks noGrp="1"/>
+          </p:cNvSpPr>
+          <p:nvPr>
+            <p:ph type="body" idx="1"/>
+          </p:nvPr>
+        </p:nvSpPr>
+        <p:spPr/>
+        <p:txBody>
+          <a:bodyPr/>
+          <a:lstStyle/>
+          <a:p>
+            <a:r>
+              <a:t>Talking points:</a:t>
+            </a:r>
+          </a:p>
+          <a:p>
+            <a:r>
+              <a:t>- Adapter: converts an interface into the one its users expect</a:t>
+            </a:r>
+          </a:p>
+          <a:p>
+            <a:r>
+              <a:t>  - PhysicsBody wraps a Box2D body: pixels, clockwise, our types</a:t>
+            </a:r>
+          </a:p>
+          <a:p>
+            <a:r>
+              <a:t>- Facade: one simple interface in front of a subsystem</a:t>
+            </a:r>
+          </a:p>
+          <a:p>
+            <a:r>
+              <a:t>  - Box2D has hundreds of functions; the game needs a handful</a:t>
+            </a:r>
+          </a:p>
+          <a:p>
+            <a:r>
+              <a:t>  - PhysicsWorld: create a box or a circle, step, destroy</a:t>
+            </a:r>
+          </a:p>
+          <a:p>
+            <a:r>
+              <a:t>- The rest of the game never sees a Box2D type</a:t>
+            </a:r>
           </a:p>
         </p:txBody>
       </p:sp>
@@ -6708,7 +7237,7 @@
         <p:spPr>
           <a:xfrm>
             <a:off x="311700" y="885950"/>
-            <a:ext cx="8520600" cy="4023300"/>
+            <a:ext cx="8520600" cy="521208"/>
           </a:xfrm>
           <a:prstGeom prst="rect">
             <a:avLst/>
@@ -6732,111 +7261,326 @@
             </a:pPr>
             <a:r>
               <a:rPr lang="en"/>
-              <a:t>A block exists twice: an entity, and a body</a:t>
+              <a:t>A block exists twice. The physics world owns where it is.</a:t>
             </a:r>
             <a:endParaRPr/>
           </a:p>
-          <a:p>
-            <a:pPr indent="-330200" lvl="0" marL="457200" rtl="0" algn="l">
-              <a:spcBef>
-                <a:spcPts val="0"/>
-              </a:spcBef>
-              <a:spcAft>
-                <a:spcPts val="0"/>
-              </a:spcAft>
-              <a:buSzPts val="1600"/>
-              <a:buChar char="●"/>
-            </a:pPr>
-            <a:r>
-              <a:rPr lang="en"/>
-              <a:t>The physics world owns the position</a:t>
-            </a:r>
-            <a:endParaRPr/>
-          </a:p>
-          <a:p>
-            <a:pPr indent="-317500" lvl="1" marL="914400" rtl="0" algn="l">
-              <a:spcBef>
-                <a:spcPts val="0"/>
-              </a:spcBef>
-              <a:spcAft>
-                <a:spcPts val="0"/>
-              </a:spcAft>
-              <a:buSzPts val="1400"/>
-              <a:buChar char="○"/>
-            </a:pPr>
-            <a:r>
-              <a:rPr lang="en"/>
-              <a:t>An entity reads its body’s position every time it’s drawn</a:t>
-            </a:r>
-            <a:endParaRPr/>
-          </a:p>
-          <a:p>
-            <a:pPr indent="-330200" lvl="0" marL="457200" rtl="0" algn="l">
-              <a:spcBef>
-                <a:spcPts val="0"/>
-              </a:spcBef>
-              <a:spcAft>
-                <a:spcPts val="0"/>
-              </a:spcAft>
-              <a:buSzPts val="1600"/>
-              <a:buChar char="●"/>
-            </a:pPr>
-            <a:r>
-              <a:rPr lang="en"/>
-              <a:t>And the body knows its owner</a:t>
-            </a:r>
-            <a:endParaRPr/>
-          </a:p>
-          <a:p>
-            <a:pPr indent="-317500" lvl="1" marL="914400" rtl="0" algn="l">
-              <a:spcBef>
-                <a:spcPts val="0"/>
-              </a:spcBef>
-              <a:spcAft>
-                <a:spcPts val="0"/>
-              </a:spcAft>
-              <a:buSzPts val="1400"/>
-              <a:buChar char="○"/>
-            </a:pPr>
-            <a:r>
-              <a:rPr lang="en"/>
-              <a:t>So events about bodies lead back to entities</a:t>
-            </a:r>
-            <a:endParaRPr/>
-          </a:p>
-          <a:p>
-            <a:pPr indent="-330200" lvl="0" marL="457200" rtl="0" algn="l">
-              <a:spcBef>
-                <a:spcPts val="0"/>
-              </a:spcBef>
-              <a:spcAft>
-                <a:spcPts val="0"/>
-              </a:spcAft>
-              <a:buSzPts val="1600"/>
-              <a:buChar char="●"/>
-            </a:pPr>
-            <a:r>
-              <a:rPr lang="en"/>
-              <a:t>F1: what the physics world sees (awake green, asleep blue)</a:t>
-            </a:r>
-            <a:endParaRPr/>
-          </a:p>
-          <a:p>
-            <a:pPr indent="-330200" lvl="0" marL="457200" rtl="0" algn="l">
-              <a:spcBef>
-                <a:spcPts val="0"/>
-              </a:spcBef>
-              <a:spcAft>
-                <a:spcPts val="0"/>
-              </a:spcAft>
-              <a:buSzPts val="1600"/>
-              <a:buChar char="●"/>
-            </a:pPr>
-            <a:r>
-              <a:rPr lang="en"/>
-              <a:t>A fixed time step: Snake’s accumulator, again</a:t>
-            </a:r>
-            <a:endParaRPr/>
+        </p:txBody>
+      </p:sp>
+      <p:sp>
+        <p:nvSpPr>
+          <p:cNvPr id="295" name="Rounded Rectangle 294"/>
+          <p:cNvSpPr/>
+          <p:nvPr/>
+        </p:nvSpPr>
+        <p:spPr>
+          <a:xfrm>
+            <a:off x="731520" y="1463040"/>
+            <a:ext cx="3108960" cy="1005840"/>
+          </a:xfrm>
+          <a:prstGeom prst="roundRect">
+            <a:avLst>
+              <a:gd name="adj" fmla="val 12000"/>
+            </a:avLst>
+          </a:prstGeom>
+          <a:solidFill>
+            <a:srgbClr val="2E3338"/>
+          </a:solidFill>
+          <a:ln>
+            <a:noFill/>
+          </a:ln>
+          <a:effectLst/>
+        </p:spPr>
+        <p:style>
+          <a:lnRef idx="1">
+            <a:schemeClr val="accent1"/>
+          </a:lnRef>
+          <a:fillRef idx="3">
+            <a:schemeClr val="accent1"/>
+          </a:fillRef>
+          <a:effectRef idx="2">
+            <a:schemeClr val="accent1"/>
+          </a:effectRef>
+          <a:fontRef idx="minor">
+            <a:schemeClr val="lt1"/>
+          </a:fontRef>
+        </p:style>
+        <p:txBody>
+          <a:bodyPr rtlCol="0" anchor="ctr" wrap="square" lIns="73152" rIns="73152"/>
+          <a:lstStyle/>
+          <a:p>
+            <a:pPr algn="ctr"/>
+            <a:r>
+              <a:rPr sz="1600" b="1">
+                <a:solidFill>
+                  <a:srgbClr val="DEE2E6"/>
+                </a:solidFill>
+              </a:rPr>
+              <a:t>Entity</a:t>
+            </a:r>
+          </a:p>
+          <a:p>
+            <a:pPr algn="ctr"/>
+            <a:r>
+              <a:rPr sz="1400" b="0">
+                <a:solidFill>
+                  <a:srgbClr val="9AA3AB"/>
+                </a:solidFill>
+              </a:rPr>
+              <a:t>sprite, health, damage</a:t>
+            </a:r>
+          </a:p>
+        </p:txBody>
+      </p:sp>
+      <p:sp>
+        <p:nvSpPr>
+          <p:cNvPr id="296" name="Rounded Rectangle 295"/>
+          <p:cNvSpPr/>
+          <p:nvPr/>
+        </p:nvSpPr>
+        <p:spPr>
+          <a:xfrm>
+            <a:off x="5303520" y="1463040"/>
+            <a:ext cx="3108960" cy="1005840"/>
+          </a:xfrm>
+          <a:prstGeom prst="roundRect">
+            <a:avLst>
+              <a:gd name="adj" fmla="val 12000"/>
+            </a:avLst>
+          </a:prstGeom>
+          <a:solidFill>
+            <a:srgbClr val="2E3338"/>
+          </a:solidFill>
+          <a:ln w="25400">
+            <a:solidFill>
+              <a:srgbClr val="D45D35"/>
+            </a:solidFill>
+          </a:ln>
+          <a:effectLst/>
+        </p:spPr>
+        <p:style>
+          <a:lnRef idx="1">
+            <a:schemeClr val="accent1"/>
+          </a:lnRef>
+          <a:fillRef idx="3">
+            <a:schemeClr val="accent1"/>
+          </a:fillRef>
+          <a:effectRef idx="2">
+            <a:schemeClr val="accent1"/>
+          </a:effectRef>
+          <a:fontRef idx="minor">
+            <a:schemeClr val="lt1"/>
+          </a:fontRef>
+        </p:style>
+        <p:txBody>
+          <a:bodyPr rtlCol="0" anchor="ctr" wrap="square" lIns="73152" rIns="73152"/>
+          <a:lstStyle/>
+          <a:p>
+            <a:pPr algn="ctr"/>
+            <a:r>
+              <a:rPr sz="1600" b="1">
+                <a:solidFill>
+                  <a:srgbClr val="DEE2E6"/>
+                </a:solidFill>
+              </a:rPr>
+              <a:t>PhysicsBody</a:t>
+            </a:r>
+          </a:p>
+          <a:p>
+            <a:pPr algn="ctr"/>
+            <a:r>
+              <a:rPr sz="1400" b="0">
+                <a:solidFill>
+                  <a:srgbClr val="9AA3AB"/>
+                </a:solidFill>
+              </a:rPr>
+              <a:t>position, rotation, velocity</a:t>
+            </a:r>
+          </a:p>
+        </p:txBody>
+      </p:sp>
+      <p:cxnSp>
+        <p:nvCxnSpPr>
+          <p:cNvPr id="297" name="Connector 296"/>
+          <p:cNvCxnSpPr/>
+          <p:nvPr/>
+        </p:nvCxnSpPr>
+        <p:spPr>
+          <a:xfrm flipH="1">
+            <a:off x="3886200" y="1783080"/>
+            <a:ext cx="1371600" cy="0"/>
+          </a:xfrm>
+          <a:prstGeom prst="line">
+            <a:avLst/>
+          </a:prstGeom>
+          <a:ln w="25400">
+            <a:solidFill>
+              <a:srgbClr val="D45D35"/>
+            </a:solidFill>
+            <a:tailEnd type="triangle"/>
+          </a:ln>
+        </p:spPr>
+        <p:style>
+          <a:lnRef idx="2">
+            <a:schemeClr val="accent1"/>
+          </a:lnRef>
+          <a:fillRef idx="0">
+            <a:schemeClr val="accent1"/>
+          </a:fillRef>
+          <a:effectRef idx="1">
+            <a:schemeClr val="accent1"/>
+          </a:effectRef>
+          <a:fontRef idx="minor">
+            <a:schemeClr val="tx1"/>
+          </a:fontRef>
+        </p:style>
+      </p:cxnSp>
+      <p:sp>
+        <p:nvSpPr>
+          <p:cNvPr id="298" name="TextBox 297"/>
+          <p:cNvSpPr txBox="1"/>
+          <p:nvPr/>
+        </p:nvSpPr>
+        <p:spPr>
+          <a:xfrm>
+            <a:off x="3703320" y="1490472"/>
+            <a:ext cx="1737360" cy="274320"/>
+          </a:xfrm>
+          <a:prstGeom prst="rect">
+            <a:avLst/>
+          </a:prstGeom>
+          <a:noFill/>
+        </p:spPr>
+        <p:txBody>
+          <a:bodyPr wrap="square">
+            <a:spAutoFit/>
+          </a:bodyPr>
+          <a:lstStyle/>
+          <a:p>
+            <a:pPr algn="ctr"/>
+            <a:r>
+              <a:rPr sz="1100" b="0" i="0">
+                <a:solidFill>
+                  <a:srgbClr val="9AA3AB"/>
+                </a:solidFill>
+              </a:rPr>
+              <a:t>position, every draw</a:t>
+            </a:r>
+          </a:p>
+        </p:txBody>
+      </p:sp>
+      <p:cxnSp>
+        <p:nvCxnSpPr>
+          <p:cNvPr id="299" name="Connector 298"/>
+          <p:cNvCxnSpPr/>
+          <p:nvPr/>
+        </p:nvCxnSpPr>
+        <p:spPr>
+          <a:xfrm>
+            <a:off x="3886200" y="2194560"/>
+            <a:ext cx="1371600" cy="0"/>
+          </a:xfrm>
+          <a:prstGeom prst="line">
+            <a:avLst/>
+          </a:prstGeom>
+          <a:ln w="25400">
+            <a:solidFill>
+              <a:srgbClr val="9AA3AB"/>
+            </a:solidFill>
+            <a:tailEnd type="triangle"/>
+          </a:ln>
+        </p:spPr>
+        <p:style>
+          <a:lnRef idx="2">
+            <a:schemeClr val="accent1"/>
+          </a:lnRef>
+          <a:fillRef idx="0">
+            <a:schemeClr val="accent1"/>
+          </a:fillRef>
+          <a:effectRef idx="1">
+            <a:schemeClr val="accent1"/>
+          </a:effectRef>
+          <a:fontRef idx="minor">
+            <a:schemeClr val="tx1"/>
+          </a:fontRef>
+        </p:style>
+      </p:cxnSp>
+      <p:sp>
+        <p:nvSpPr>
+          <p:cNvPr id="300" name="TextBox 299"/>
+          <p:cNvSpPr txBox="1"/>
+          <p:nvPr/>
+        </p:nvSpPr>
+        <p:spPr>
+          <a:xfrm>
+            <a:off x="3886200" y="2240280"/>
+            <a:ext cx="1371600" cy="274320"/>
+          </a:xfrm>
+          <a:prstGeom prst="rect">
+            <a:avLst/>
+          </a:prstGeom>
+          <a:noFill/>
+        </p:spPr>
+        <p:txBody>
+          <a:bodyPr wrap="square">
+            <a:spAutoFit/>
+          </a:bodyPr>
+          <a:lstStyle/>
+          <a:p>
+            <a:pPr algn="ctr"/>
+            <a:r>
+              <a:rPr sz="1100" b="0" i="0">
+                <a:solidFill>
+                  <a:srgbClr val="9AA3AB"/>
+                </a:solidFill>
+              </a:rPr>
+              <a:t>Owner</a:t>
+            </a:r>
+          </a:p>
+        </p:txBody>
+      </p:sp>
+      <p:sp>
+        <p:nvSpPr>
+          <p:cNvPr id="301" name="TextBox 300"/>
+          <p:cNvSpPr txBox="1"/>
+          <p:nvPr/>
+        </p:nvSpPr>
+        <p:spPr>
+          <a:xfrm>
+            <a:off x="731520" y="2743200"/>
+            <a:ext cx="7680960" cy="822960"/>
+          </a:xfrm>
+          <a:prstGeom prst="rect">
+            <a:avLst/>
+          </a:prstGeom>
+          <a:noFill/>
+        </p:spPr>
+        <p:txBody>
+          <a:bodyPr wrap="square">
+            <a:spAutoFit/>
+          </a:bodyPr>
+          <a:lstStyle/>
+          <a:p>
+            <a:pPr algn="ctr"/>
+            <a:r>
+              <a:rPr sz="1400" b="0" i="0">
+                <a:solidFill>
+                  <a:srgbClr val="9AA3AB"/>
+                </a:solidFill>
+              </a:rPr>
+              <a:t>The body knows its owner, so a hit between two bodies leads back to two entities.</a:t>
+            </a:r>
+          </a:p>
+          <a:p>
+            <a:pPr algn="ctr"/>
+            <a:r>
+              <a:rPr sz="1400" b="0" i="0">
+                <a:solidFill>
+                  <a:srgbClr val="9AA3AB"/>
+                </a:solidFill>
+              </a:rPr>
+              <a:t>F1 shows what the physics world sees. A fixed time step: Snake’s accumulator again.</a:t>
+            </a:r>
           </a:p>
         </p:txBody>
       </p:sp>
@@ -10415,7 +11159,7 @@
         <p:spPr>
           <a:xfrm>
             <a:off x="311700" y="885950"/>
-            <a:ext cx="8520600" cy="4023300"/>
+            <a:ext cx="8520600" cy="521208"/>
           </a:xfrm>
           <a:prstGeom prst="rect">
             <a:avLst/>
@@ -10439,94 +11183,318 @@
             </a:pPr>
             <a:r>
               <a:rPr lang="en"/>
-              <a:t>Three levels, a few birds each</a:t>
+              <a:t>Three levels, a few birds each. Fly waits until the world has settled.</a:t>
             </a:r>
             <a:endParaRPr/>
           </a:p>
-          <a:p>
-            <a:pPr indent="-330200" lvl="0" marL="457200" rtl="0" algn="l">
-              <a:spcBef>
-                <a:spcPts val="0"/>
-              </a:spcBef>
-              <a:spcAft>
-                <a:spcPts val="0"/>
-              </a:spcAft>
-              <a:buSzPts val="1600"/>
-              <a:buChar char="●"/>
-            </a:pPr>
-            <a:r>
-              <a:rPr lang="en"/>
-              <a:t>Game states: Aim → Fly → Aim or Level End</a:t>
-            </a:r>
-            <a:endParaRPr/>
-          </a:p>
-          <a:p>
-            <a:pPr indent="-330200" lvl="0" marL="457200" rtl="0" algn="l">
-              <a:spcBef>
-                <a:spcPts val="0"/>
-              </a:spcBef>
-              <a:spcAft>
-                <a:spcPts val="0"/>
-              </a:spcAft>
-              <a:buSzPts val="1600"/>
-              <a:buChar char="●"/>
-            </a:pPr>
-            <a:r>
-              <a:rPr lang="en"/>
-              <a:t>Fly waits until the world has settled</a:t>
-            </a:r>
-            <a:endParaRPr/>
-          </a:p>
-          <a:p>
-            <a:pPr indent="-317500" lvl="1" marL="914400" rtl="0" algn="l">
-              <a:spcBef>
-                <a:spcPts val="0"/>
-              </a:spcBef>
-              <a:spcAft>
-                <a:spcPts val="0"/>
-              </a:spcAft>
-              <a:buSzPts val="1400"/>
-              <a:buChar char="○"/>
-            </a:pPr>
-            <a:r>
-              <a:rPr lang="en"/>
-              <a:t>The facade answers it in one line: IsSettled</a:t>
-            </a:r>
-            <a:endParaRPr/>
-          </a:p>
-          <a:p>
-            <a:pPr indent="-330200" lvl="0" marL="457200" rtl="0" algn="l">
-              <a:spcBef>
-                <a:spcPts val="0"/>
-              </a:spcBef>
-              <a:spcAft>
-                <a:spcPts val="0"/>
-              </a:spcAft>
-              <a:buSzPts val="1600"/>
-              <a:buChar char="●"/>
-            </a:pPr>
-            <a:r>
-              <a:rPr lang="en"/>
-              <a:t>The aiming curve doesn’t use the physics world</a:t>
-            </a:r>
-            <a:endParaRPr/>
-          </a:p>
-          <a:p>
-            <a:pPr indent="-317500" lvl="1" marL="914400" rtl="0" algn="l">
-              <a:spcBef>
-                <a:spcPts val="0"/>
-              </a:spcBef>
-              <a:spcAft>
-                <a:spcPts val="0"/>
-              </a:spcAft>
-              <a:buSzPts val="1400"/>
-              <a:buChar char="○"/>
-            </a:pPr>
-            <a:r>
-              <a:rPr lang="en"/>
-              <a:t>start + velocity × t + gravity × t² / 2</a:t>
-            </a:r>
-            <a:endParaRPr/>
+        </p:txBody>
+      </p:sp>
+      <p:sp>
+        <p:nvSpPr>
+          <p:cNvPr id="295" name="Rounded Rectangle 294"/>
+          <p:cNvSpPr/>
+          <p:nvPr/>
+        </p:nvSpPr>
+        <p:spPr>
+          <a:xfrm>
+            <a:off x="1463040" y="1463040"/>
+            <a:ext cx="1828800" cy="548640"/>
+          </a:xfrm>
+          <a:prstGeom prst="roundRect">
+            <a:avLst>
+              <a:gd name="adj" fmla="val 12000"/>
+            </a:avLst>
+          </a:prstGeom>
+          <a:solidFill>
+            <a:srgbClr val="2E3338"/>
+          </a:solidFill>
+          <a:ln w="25400">
+            <a:solidFill>
+              <a:srgbClr val="D45D35"/>
+            </a:solidFill>
+          </a:ln>
+          <a:effectLst/>
+        </p:spPr>
+        <p:style>
+          <a:lnRef idx="1">
+            <a:schemeClr val="accent1"/>
+          </a:lnRef>
+          <a:fillRef idx="3">
+            <a:schemeClr val="accent1"/>
+          </a:fillRef>
+          <a:effectRef idx="2">
+            <a:schemeClr val="accent1"/>
+          </a:effectRef>
+          <a:fontRef idx="minor">
+            <a:schemeClr val="lt1"/>
+          </a:fontRef>
+        </p:style>
+        <p:txBody>
+          <a:bodyPr rtlCol="0" anchor="ctr" wrap="square" lIns="73152" rIns="73152"/>
+          <a:lstStyle/>
+          <a:p>
+            <a:pPr algn="ctr"/>
+            <a:r>
+              <a:rPr sz="1500" b="1">
+                <a:solidFill>
+                  <a:srgbClr val="DEE2E6"/>
+                </a:solidFill>
+              </a:rPr>
+              <a:t>Aim</a:t>
+            </a:r>
+          </a:p>
+        </p:txBody>
+      </p:sp>
+      <p:cxnSp>
+        <p:nvCxnSpPr>
+          <p:cNvPr id="296" name="Connector 295"/>
+          <p:cNvCxnSpPr/>
+          <p:nvPr/>
+        </p:nvCxnSpPr>
+        <p:spPr>
+          <a:xfrm>
+            <a:off x="3310128" y="1737360"/>
+            <a:ext cx="237744" cy="0"/>
+          </a:xfrm>
+          <a:prstGeom prst="line">
+            <a:avLst/>
+          </a:prstGeom>
+          <a:ln w="25400">
+            <a:solidFill>
+              <a:srgbClr val="9AA3AB"/>
+            </a:solidFill>
+            <a:tailEnd type="triangle"/>
+          </a:ln>
+        </p:spPr>
+        <p:style>
+          <a:lnRef idx="2">
+            <a:schemeClr val="accent1"/>
+          </a:lnRef>
+          <a:fillRef idx="0">
+            <a:schemeClr val="accent1"/>
+          </a:fillRef>
+          <a:effectRef idx="1">
+            <a:schemeClr val="accent1"/>
+          </a:effectRef>
+          <a:fontRef idx="minor">
+            <a:schemeClr val="tx1"/>
+          </a:fontRef>
+        </p:style>
+      </p:cxnSp>
+      <p:sp>
+        <p:nvSpPr>
+          <p:cNvPr id="297" name="Rounded Rectangle 296"/>
+          <p:cNvSpPr/>
+          <p:nvPr/>
+        </p:nvSpPr>
+        <p:spPr>
+          <a:xfrm>
+            <a:off x="3566160" y="1463040"/>
+            <a:ext cx="1828800" cy="548640"/>
+          </a:xfrm>
+          <a:prstGeom prst="roundRect">
+            <a:avLst>
+              <a:gd name="adj" fmla="val 12000"/>
+            </a:avLst>
+          </a:prstGeom>
+          <a:solidFill>
+            <a:srgbClr val="2E3338"/>
+          </a:solidFill>
+          <a:ln>
+            <a:noFill/>
+          </a:ln>
+          <a:effectLst/>
+        </p:spPr>
+        <p:style>
+          <a:lnRef idx="1">
+            <a:schemeClr val="accent1"/>
+          </a:lnRef>
+          <a:fillRef idx="3">
+            <a:schemeClr val="accent1"/>
+          </a:fillRef>
+          <a:effectRef idx="2">
+            <a:schemeClr val="accent1"/>
+          </a:effectRef>
+          <a:fontRef idx="minor">
+            <a:schemeClr val="lt1"/>
+          </a:fontRef>
+        </p:style>
+        <p:txBody>
+          <a:bodyPr rtlCol="0" anchor="ctr" wrap="square" lIns="73152" rIns="73152"/>
+          <a:lstStyle/>
+          <a:p>
+            <a:pPr algn="ctr"/>
+            <a:r>
+              <a:rPr sz="1500" b="1">
+                <a:solidFill>
+                  <a:srgbClr val="DEE2E6"/>
+                </a:solidFill>
+              </a:rPr>
+              <a:t>Fly</a:t>
+            </a:r>
+          </a:p>
+        </p:txBody>
+      </p:sp>
+      <p:cxnSp>
+        <p:nvCxnSpPr>
+          <p:cNvPr id="298" name="Connector 297"/>
+          <p:cNvCxnSpPr/>
+          <p:nvPr/>
+        </p:nvCxnSpPr>
+        <p:spPr>
+          <a:xfrm>
+            <a:off x="5413248" y="1737360"/>
+            <a:ext cx="237744" cy="0"/>
+          </a:xfrm>
+          <a:prstGeom prst="line">
+            <a:avLst/>
+          </a:prstGeom>
+          <a:ln w="25400">
+            <a:solidFill>
+              <a:srgbClr val="9AA3AB"/>
+            </a:solidFill>
+            <a:tailEnd type="triangle"/>
+          </a:ln>
+        </p:spPr>
+        <p:style>
+          <a:lnRef idx="2">
+            <a:schemeClr val="accent1"/>
+          </a:lnRef>
+          <a:fillRef idx="0">
+            <a:schemeClr val="accent1"/>
+          </a:fillRef>
+          <a:effectRef idx="1">
+            <a:schemeClr val="accent1"/>
+          </a:effectRef>
+          <a:fontRef idx="minor">
+            <a:schemeClr val="tx1"/>
+          </a:fontRef>
+        </p:style>
+      </p:cxnSp>
+      <p:sp>
+        <p:nvSpPr>
+          <p:cNvPr id="299" name="Rounded Rectangle 298"/>
+          <p:cNvSpPr/>
+          <p:nvPr/>
+        </p:nvSpPr>
+        <p:spPr>
+          <a:xfrm>
+            <a:off x="5669279" y="1463040"/>
+            <a:ext cx="1828800" cy="548640"/>
+          </a:xfrm>
+          <a:prstGeom prst="roundRect">
+            <a:avLst>
+              <a:gd name="adj" fmla="val 12000"/>
+            </a:avLst>
+          </a:prstGeom>
+          <a:solidFill>
+            <a:srgbClr val="2E3338"/>
+          </a:solidFill>
+          <a:ln>
+            <a:noFill/>
+          </a:ln>
+          <a:effectLst/>
+        </p:spPr>
+        <p:style>
+          <a:lnRef idx="1">
+            <a:schemeClr val="accent1"/>
+          </a:lnRef>
+          <a:fillRef idx="3">
+            <a:schemeClr val="accent1"/>
+          </a:fillRef>
+          <a:effectRef idx="2">
+            <a:schemeClr val="accent1"/>
+          </a:effectRef>
+          <a:fontRef idx="minor">
+            <a:schemeClr val="lt1"/>
+          </a:fontRef>
+        </p:style>
+        <p:txBody>
+          <a:bodyPr rtlCol="0" anchor="ctr" wrap="square" lIns="73152" rIns="73152"/>
+          <a:lstStyle/>
+          <a:p>
+            <a:pPr algn="ctr"/>
+            <a:r>
+              <a:rPr sz="1500" b="1">
+                <a:solidFill>
+                  <a:srgbClr val="DEE2E6"/>
+                </a:solidFill>
+              </a:rPr>
+              <a:t>Aim again, or Level End</a:t>
+            </a:r>
+          </a:p>
+        </p:txBody>
+      </p:sp>
+      <p:sp>
+        <p:nvSpPr>
+          <p:cNvPr id="300" name="Rectangle 299"/>
+          <p:cNvSpPr/>
+          <p:nvPr/>
+        </p:nvSpPr>
+        <p:spPr>
+          <a:xfrm>
+            <a:off x="914400" y="2468880"/>
+            <a:ext cx="7315200" cy="685800"/>
+          </a:xfrm>
+          <a:prstGeom prst="rect">
+            <a:avLst/>
+          </a:prstGeom>
+          <a:solidFill>
+            <a:srgbClr val="17191C"/>
+          </a:solidFill>
+          <a:ln>
+            <a:noFill/>
+          </a:ln>
+          <a:effectLst/>
+        </p:spPr>
+        <p:style>
+          <a:lnRef idx="1">
+            <a:schemeClr val="accent1"/>
+          </a:lnRef>
+          <a:fillRef idx="3">
+            <a:schemeClr val="accent1"/>
+          </a:fillRef>
+          <a:effectRef idx="2">
+            <a:schemeClr val="accent1"/>
+          </a:effectRef>
+          <a:fontRef idx="minor">
+            <a:schemeClr val="lt1"/>
+          </a:fontRef>
+        </p:style>
+        <p:txBody>
+          <a:bodyPr rtlCol="0" anchor="ctr" wrap="square" lIns="164592" rIns="73152"/>
+          <a:lstStyle/>
+          <a:p>
+            <a:pPr algn="l"/>
+            <a:r>
+              <a:rPr sz="1400" b="0">
+                <a:solidFill>
+                  <a:srgbClr val="DEE2E6"/>
+                </a:solidFill>
+              </a:rPr>
+              <a:t/>
+            </a:r>
+            <a:r>
+              <a:rPr sz="1300">
+                <a:solidFill>
+                  <a:srgbClr val="9AA3AB"/>
+                </a:solidFill>
+                <a:latin typeface="Consolas"/>
+              </a:rPr>
+              <a:t>// the aiming curve: no physics world needed</a:t>
+            </a:r>
+          </a:p>
+          <a:p>
+            <a:pPr algn="l"/>
+            <a:r>
+              <a:rPr sz="1300">
+                <a:solidFill>
+                  <a:srgbClr val="DEE2E6"/>
+                </a:solidFill>
+                <a:latin typeface="Consolas"/>
+              </a:rPr>
+              <a:t>position = start + velocity * t + gravity * t * t / 2</a:t>
+            </a:r>
           </a:p>
         </p:txBody>
       </p:sp>
@@ -13342,6 +14310,179 @@
 </p:sld>
 </file>
 
+<file path=ppt/slides/slide26.xml><?xml version="1.0" encoding="utf-8"?>
+<p:sld xmlns:a="http://schemas.openxmlformats.org/drawingml/2006/main" xmlns:p="http://schemas.openxmlformats.org/presentationml/2006/main" xmlns:r="http://schemas.openxmlformats.org/officeDocument/2006/relationships">
+  <p:cSld>
+    <p:spTree>
+      <p:nvGrpSpPr>
+        <p:cNvPr id="1" name=""/>
+        <p:cNvGrpSpPr/>
+        <p:nvPr/>
+      </p:nvGrpSpPr>
+      <p:grpSpPr/>
+      <p:sp>
+        <p:nvSpPr>
+          <p:cNvPr id="2" name="Title 1"/>
+          <p:cNvSpPr>
+            <a:spLocks noGrp="1"/>
+          </p:cNvSpPr>
+          <p:nvPr>
+            <p:ph type="title"/>
+          </p:nvPr>
+        </p:nvSpPr>
+        <p:spPr/>
+        <p:txBody>
+          <a:bodyPr/>
+          <a:lstStyle/>
+          <a:p>
+            <a:pPr indent="0" lvl="0" marL="0" rtl="0" algn="l">
+              <a:spcBef>
+                <a:spcPts val="0"/>
+              </a:spcBef>
+              <a:spcAft>
+                <a:spcPts val="0"/>
+              </a:spcAft>
+              <a:buNone/>
+            </a:pPr>
+            <a:r>
+              <a:rPr lang="en"/>
+              <a:t>Check Yourself</a:t>
+            </a:r>
+            <a:endParaRPr/>
+          </a:p>
+        </p:txBody>
+      </p:sp>
+      <p:sp>
+        <p:nvSpPr>
+          <p:cNvPr id="3" name="Text Placeholder 2"/>
+          <p:cNvSpPr>
+            <a:spLocks noGrp="1"/>
+          </p:cNvSpPr>
+          <p:nvPr>
+            <p:ph type="body" idx="1"/>
+          </p:nvPr>
+        </p:nvSpPr>
+        <p:spPr>
+          <a:xfrm>
+            <a:off x="311700" y="885950"/>
+            <a:ext cx="8520600" cy="1719072"/>
+          </a:xfrm>
+        </p:spPr>
+        <p:txBody>
+          <a:bodyPr/>
+          <a:lstStyle/>
+          <a:p>
+            <a:pPr indent="-330200" lvl="0" marL="457200" rtl="0" algn="l">
+              <a:spcBef>
+                <a:spcPts val="0"/>
+              </a:spcBef>
+              <a:spcAft>
+                <a:spcPts val="0"/>
+              </a:spcAft>
+              <a:buSzPts val="1600"/>
+              <a:buChar char="●"/>
+            </a:pPr>
+            <a:r>
+              <a:rPr lang="en"/>
+              <a:t>What is the difference between an Adapter and a Facade?</a:t>
+            </a:r>
+            <a:endParaRPr/>
+          </a:p>
+          <a:p>
+            <a:pPr indent="-330200" lvl="0" marL="457200" rtl="0" algn="l">
+              <a:spcBef>
+                <a:spcPts val="0"/>
+              </a:spcBef>
+              <a:spcAft>
+                <a:spcPts val="0"/>
+              </a:spcAft>
+              <a:buSzPts val="1600"/>
+              <a:buChar char="●"/>
+            </a:pPr>
+            <a:r>
+              <a:rPr lang="en"/>
+              <a:t>Why convert between metres and pixels at all?</a:t>
+            </a:r>
+            <a:endParaRPr/>
+          </a:p>
+          <a:p>
+            <a:pPr indent="-330200" lvl="0" marL="457200" rtl="0" algn="l">
+              <a:spcBef>
+                <a:spcPts val="0"/>
+              </a:spcBef>
+              <a:spcAft>
+                <a:spcPts val="0"/>
+              </a:spcAft>
+              <a:buSzPts val="1600"/>
+              <a:buChar char="●"/>
+            </a:pPr>
+            <a:r>
+              <a:rPr lang="en"/>
+              <a:t>Why not destroy a body inside the hit handler?</a:t>
+            </a:r>
+            <a:endParaRPr/>
+          </a:p>
+          <a:p>
+            <a:pPr indent="-330200" lvl="0" marL="457200" rtl="0" algn="l">
+              <a:spcBef>
+                <a:spcPts val="0"/>
+              </a:spcBef>
+              <a:spcAft>
+                <a:spcPts val="0"/>
+              </a:spcAft>
+              <a:buSzPts val="1600"/>
+              <a:buChar char="●"/>
+            </a:pPr>
+            <a:r>
+              <a:rPr lang="en"/>
+              <a:t>What does a shallow copy share with the original, and why does it matter?</a:t>
+            </a:r>
+            <a:endParaRPr/>
+          </a:p>
+        </p:txBody>
+      </p:sp>
+      <p:sp>
+        <p:nvSpPr>
+          <p:cNvPr id="4" name="TextBox 3"/>
+          <p:cNvSpPr txBox="1"/>
+          <p:nvPr/>
+        </p:nvSpPr>
+        <p:spPr>
+          <a:xfrm>
+            <a:off x="457200" y="3182112"/>
+            <a:ext cx="8229600" cy="457200"/>
+          </a:xfrm>
+          <a:prstGeom prst="rect">
+            <a:avLst/>
+          </a:prstGeom>
+          <a:noFill/>
+        </p:spPr>
+        <p:txBody>
+          <a:bodyPr wrap="square">
+            <a:spAutoFit/>
+          </a:bodyPr>
+          <a:lstStyle/>
+          <a:p>
+            <a:pPr algn="ctr"/>
+            <a:r>
+              <a:rPr sz="1400" b="0" i="0">
+                <a:solidFill>
+                  <a:srgbClr val="9AA3AB"/>
+                </a:solidFill>
+              </a:rPr>
+              <a:t>The answers, and more questions, are on the course site.</a:t>
+            </a:r>
+          </a:p>
+        </p:txBody>
+      </p:sp>
+    </p:spTree>
+  </p:cSld>
+  <p:clrMapOvr>
+    <a:masterClrMapping/>
+  </p:clrMapOvr>
+</p:sld>
+</file>
+
 <file path=ppt/slides/slide3.xml><?xml version="1.0" encoding="utf-8"?>
 <p:sld xmlns:a="http://schemas.openxmlformats.org/drawingml/2006/main" xmlns:r="http://schemas.openxmlformats.org/officeDocument/2006/relationships" xmlns:mc="http://schemas.openxmlformats.org/markup-compatibility/2006" xmlns:mv="urn:schemas-microsoft-com:mac:vml" xmlns:p="http://schemas.openxmlformats.org/presentationml/2006/main" xmlns:c="http://schemas.openxmlformats.org/drawingml/2006/chart" xmlns:dgm="http://schemas.openxmlformats.org/drawingml/2006/diagram" xmlns:o="urn:schemas-microsoft-com:office:office" xmlns:v="urn:schemas-microsoft-com:vml" xmlns:pvml="urn:schemas-microsoft-com:office:powerpoint" xmlns:com="http://schemas.openxmlformats.org/drawingml/2006/compatibility" xmlns:p14="http://schemas.microsoft.com/office/powerpoint/2010/main" xmlns:p15="http://schemas.microsoft.com/office/powerpoint/2012/main" xmlns:ahyp="http://schemas.microsoft.com/office/drawing/2018/hyperlinkcolor">
   <p:cSld>
@@ -13876,7 +15017,7 @@
         <p:spPr>
           <a:xfrm>
             <a:off x="311700" y="885950"/>
-            <a:ext cx="8520600" cy="4023300"/>
+            <a:ext cx="8520600" cy="1289304"/>
           </a:xfrm>
           <a:prstGeom prst="rect">
             <a:avLst/>
@@ -13900,29 +15041,7 @@
             </a:pPr>
             <a:r>
               <a:rPr lang="en"/>
-              <a:t>All Source code for today’s game can be found here:</a:t>
-            </a:r>
-            <a:endParaRPr/>
-          </a:p>
-          <a:p>
-            <a:pPr indent="-317500" lvl="1" marL="914400" rtl="0" algn="l">
-              <a:spcBef>
-                <a:spcPts val="0"/>
-              </a:spcBef>
-              <a:spcAft>
-                <a:spcPts val="0"/>
-              </a:spcAft>
-              <a:buSzPts val="1400"/>
-              <a:buChar char="○"/>
-            </a:pPr>
-            <a:r>
-              <a:rPr lang="en" u="sng">
-                <a:solidFill>
-                  <a:schemeClr val="hlink"/>
-                </a:solidFill>
-                <a:hlinkClick r:id="rId3"/>
-              </a:rPr>
-              <a:t>github.com/Metamate/gar-games (folder 07-angry-birds)</a:t>
+              <a:t>github.com/Metamate/gar-games, folder 07-angry-birds</a:t>
             </a:r>
             <a:endParaRPr/>
           </a:p>
@@ -13939,41 +15058,7 @@
             </a:pPr>
             <a:r>
               <a:rPr lang="en"/>
-              <a:t>The game is built up in steps: Birds0 → Birds4</a:t>
-            </a:r>
-            <a:endParaRPr/>
-          </a:p>
-          <a:p>
-            <a:pPr indent="-317500" lvl="1" marL="914400" rtl="0" algn="l">
-              <a:spcBef>
-                <a:spcPts val="0"/>
-              </a:spcBef>
-              <a:spcAft>
-                <a:spcPts val="0"/>
-              </a:spcAft>
-              <a:buSzPts val="1400"/>
-              <a:buChar char="○"/>
-            </a:pPr>
-            <a:r>
-              <a:rPr lang="en"/>
-              <a:t>Each step is a separate project that adds one concept</a:t>
-            </a:r>
-            <a:endParaRPr/>
-          </a:p>
-          <a:p>
-            <a:pPr indent="-317500" lvl="1" marL="914400" rtl="0" algn="l">
-              <a:spcBef>
-                <a:spcPts val="0"/>
-              </a:spcBef>
-              <a:spcAft>
-                <a:spcPts val="0"/>
-              </a:spcAft>
-              <a:buSzPts val="1400"/>
-              <a:buChar char="○"/>
-            </a:pPr>
-            <a:r>
-              <a:rPr lang="en"/>
-              <a:t>Compare neighbouring steps to see exactly what changed</a:t>
+              <a:t>Its README: the steps (Birds0 to Birds4), a map of the code, how to run it</a:t>
             </a:r>
             <a:endParaRPr/>
           </a:p>
@@ -13990,7 +15075,7 @@
             </a:pPr>
             <a:r>
               <a:rPr lang="en"/>
-              <a:t>Birds4 is the finished game, and the starting point for the exercises</a:t>
+              <a:t>The course site: today’s concepts in full, the exercises, and questions to check yourself</a:t>
             </a:r>
             <a:endParaRPr/>
           </a:p>
@@ -14073,7 +15158,7 @@
         <p:spPr>
           <a:xfrm>
             <a:off x="311700" y="885950"/>
-            <a:ext cx="8520600" cy="4023300"/>
+            <a:ext cx="8520600" cy="521208"/>
           </a:xfrm>
           <a:prstGeom prst="rect">
             <a:avLst/>
@@ -14097,111 +15182,397 @@
             </a:pPr>
             <a:r>
               <a:rPr lang="en"/>
-              <a:t>Stacks that tip, bounce and break: more than Mario’s physics</a:t>
+              <a:t>Stacks that tip, bounce and break: we use Box2D, not our own physics.</a:t>
             </a:r>
             <a:endParaRPr/>
           </a:p>
-          <a:p>
-            <a:pPr indent="-330200" lvl="0" marL="457200" rtl="0" algn="l">
-              <a:spcBef>
-                <a:spcPts val="0"/>
-              </a:spcBef>
-              <a:spcAft>
-                <a:spcPts val="0"/>
-              </a:spcAft>
-              <a:buSzPts val="1600"/>
-              <a:buChar char="●"/>
-            </a:pPr>
-            <a:r>
-              <a:rPr lang="en"/>
-              <a:t>Box2D: a 2D physics engine, used in many games</a:t>
-            </a:r>
-            <a:endParaRPr/>
-          </a:p>
-          <a:p>
-            <a:pPr indent="-317500" lvl="1" marL="914400" rtl="0" algn="l">
-              <a:spcBef>
-                <a:spcPts val="0"/>
-              </a:spcBef>
-              <a:spcAft>
-                <a:spcPts val="0"/>
-              </a:spcAft>
-              <a:buSzPts val="1400"/>
-              <a:buChar char="○"/>
-            </a:pPr>
-            <a:r>
-              <a:rPr lang="en"/>
-              <a:t>Box2D.NET: a C# port, added as a NuGet package</a:t>
-            </a:r>
-            <a:endParaRPr/>
-          </a:p>
-          <a:p>
-            <a:pPr indent="-330200" lvl="0" marL="457200" rtl="0" algn="l">
-              <a:spcBef>
-                <a:spcPts val="0"/>
-              </a:spcBef>
-              <a:spcAft>
-                <a:spcPts val="0"/>
-              </a:spcAft>
-              <a:buSzPts val="1600"/>
-              <a:buChar char="●"/>
-            </a:pPr>
-            <a:r>
-              <a:rPr lang="en"/>
+        </p:txBody>
+      </p:sp>
+      <p:sp>
+        <p:nvSpPr>
+          <p:cNvPr id="295" name="Rounded Rectangle 294"/>
+          <p:cNvSpPr/>
+          <p:nvPr/>
+        </p:nvSpPr>
+        <p:spPr>
+          <a:xfrm>
+            <a:off x="548640" y="1417320"/>
+            <a:ext cx="3749039" cy="1097280"/>
+          </a:xfrm>
+          <a:prstGeom prst="roundRect">
+            <a:avLst>
+              <a:gd name="adj" fmla="val 12000"/>
+            </a:avLst>
+          </a:prstGeom>
+          <a:solidFill>
+            <a:srgbClr val="2E3338"/>
+          </a:solidFill>
+          <a:ln>
+            <a:noFill/>
+          </a:ln>
+          <a:effectLst/>
+        </p:spPr>
+        <p:style>
+          <a:lnRef idx="1">
+            <a:schemeClr val="accent1"/>
+          </a:lnRef>
+          <a:fillRef idx="3">
+            <a:schemeClr val="accent1"/>
+          </a:fillRef>
+          <a:effectRef idx="2">
+            <a:schemeClr val="accent1"/>
+          </a:effectRef>
+          <a:fontRef idx="minor">
+            <a:schemeClr val="lt1"/>
+          </a:fontRef>
+        </p:style>
+        <p:txBody>
+          <a:bodyPr rtlCol="0" anchor="ctr" wrap="square" lIns="73152" rIns="73152"/>
+          <a:lstStyle/>
+          <a:p>
+            <a:pPr algn="ctr"/>
+            <a:r>
+              <a:rPr sz="1500" b="1">
+                <a:solidFill>
+                  <a:srgbClr val="DEE2E6"/>
+                </a:solidFill>
+              </a:rPr>
               <a:t>A world of bodies</a:t>
             </a:r>
-            <a:endParaRPr/>
-          </a:p>
-          <a:p>
-            <a:pPr indent="-317500" lvl="1" marL="914400" rtl="0" algn="l">
-              <a:spcBef>
-                <a:spcPts val="0"/>
-              </a:spcBef>
-              <a:spcAft>
-                <a:spcPts val="0"/>
-              </a:spcAft>
-              <a:buSzPts val="1400"/>
-              <a:buChar char="○"/>
-            </a:pPr>
-            <a:r>
-              <a:rPr lang="en"/>
-              <a:t>Each body has shapes: boxes, circles, polygons</a:t>
-            </a:r>
-            <a:endParaRPr/>
-          </a:p>
-          <a:p>
-            <a:pPr indent="-317500" lvl="1" marL="914400" rtl="0" algn="l">
-              <a:spcBef>
-                <a:spcPts val="0"/>
-              </a:spcBef>
-              <a:spcAft>
-                <a:spcPts val="0"/>
-              </a:spcAft>
-              <a:buSzPts val="1400"/>
-              <a:buChar char="○"/>
-            </a:pPr>
-            <a:r>
-              <a:rPr lang="en"/>
-              <a:t>Static bodies never move; dynamic bodies are moved by gravity and collisions</a:t>
-            </a:r>
-            <a:endParaRPr/>
-          </a:p>
-          <a:p>
-            <a:pPr indent="-330200" lvl="0" marL="457200" rtl="0" algn="l">
-              <a:spcBef>
-                <a:spcPts val="0"/>
-              </a:spcBef>
-              <a:spcAft>
-                <a:spcPts val="0"/>
-              </a:spcAft>
-              <a:buSzPts val="1600"/>
-              <a:buChar char="●"/>
-            </a:pPr>
-            <a:r>
-              <a:rPr lang="en"/>
-              <a:t>Step the world forward, then read where the bodies are</a:t>
-            </a:r>
-            <a:endParaRPr/>
+          </a:p>
+          <a:p>
+            <a:pPr algn="ctr"/>
+            <a:r>
+              <a:rPr sz="1300" b="0">
+                <a:solidFill>
+                  <a:srgbClr val="9AA3AB"/>
+                </a:solidFill>
+              </a:rPr>
+              <a:t>static: never move (the ground)</a:t>
+            </a:r>
+          </a:p>
+          <a:p>
+            <a:pPr algn="ctr"/>
+            <a:r>
+              <a:rPr sz="1300" b="0">
+                <a:solidFill>
+                  <a:srgbClr val="9AA3AB"/>
+                </a:solidFill>
+              </a:rPr>
+              <a:t>dynamic: gravity and collisions</a:t>
+            </a:r>
+          </a:p>
+        </p:txBody>
+      </p:sp>
+      <p:sp>
+        <p:nvSpPr>
+          <p:cNvPr id="296" name="Rounded Rectangle 295"/>
+          <p:cNvSpPr/>
+          <p:nvPr/>
+        </p:nvSpPr>
+        <p:spPr>
+          <a:xfrm>
+            <a:off x="4846320" y="1417320"/>
+            <a:ext cx="3749039" cy="1097280"/>
+          </a:xfrm>
+          <a:prstGeom prst="roundRect">
+            <a:avLst>
+              <a:gd name="adj" fmla="val 12000"/>
+            </a:avLst>
+          </a:prstGeom>
+          <a:solidFill>
+            <a:srgbClr val="2E3338"/>
+          </a:solidFill>
+          <a:ln>
+            <a:noFill/>
+          </a:ln>
+          <a:effectLst/>
+        </p:spPr>
+        <p:style>
+          <a:lnRef idx="1">
+            <a:schemeClr val="accent1"/>
+          </a:lnRef>
+          <a:fillRef idx="3">
+            <a:schemeClr val="accent1"/>
+          </a:fillRef>
+          <a:effectRef idx="2">
+            <a:schemeClr val="accent1"/>
+          </a:effectRef>
+          <a:fontRef idx="minor">
+            <a:schemeClr val="lt1"/>
+          </a:fontRef>
+        </p:style>
+        <p:txBody>
+          <a:bodyPr rtlCol="0" anchor="ctr" wrap="square" lIns="73152" rIns="73152"/>
+          <a:lstStyle/>
+          <a:p>
+            <a:pPr algn="ctr"/>
+            <a:r>
+              <a:rPr sz="1500" b="1">
+                <a:solidFill>
+                  <a:srgbClr val="DEE2E6"/>
+                </a:solidFill>
+              </a:rPr>
+              <a:t>Bodies have shapes</a:t>
+            </a:r>
+          </a:p>
+          <a:p>
+            <a:pPr algn="ctr"/>
+            <a:r>
+              <a:rPr sz="1300" b="0">
+                <a:solidFill>
+                  <a:srgbClr val="9AA3AB"/>
+                </a:solidFill>
+              </a:rPr>
+              <a:t>boxes, circles, polygons</a:t>
+            </a:r>
+          </a:p>
+          <a:p>
+            <a:pPr algn="ctr"/>
+            <a:r>
+              <a:rPr sz="1300" b="0">
+                <a:solidFill>
+                  <a:srgbClr val="9AA3AB"/>
+                </a:solidFill>
+              </a:rPr>
+              <a:t>with friction and density</a:t>
+            </a:r>
+          </a:p>
+        </p:txBody>
+      </p:sp>
+      <p:sp>
+        <p:nvSpPr>
+          <p:cNvPr id="297" name="Rounded Rectangle 296"/>
+          <p:cNvSpPr/>
+          <p:nvPr/>
+        </p:nvSpPr>
+        <p:spPr>
+          <a:xfrm>
+            <a:off x="1005840" y="2834640"/>
+            <a:ext cx="2103120" cy="594360"/>
+          </a:xfrm>
+          <a:prstGeom prst="roundRect">
+            <a:avLst>
+              <a:gd name="adj" fmla="val 12000"/>
+            </a:avLst>
+          </a:prstGeom>
+          <a:solidFill>
+            <a:srgbClr val="2E3338"/>
+          </a:solidFill>
+          <a:ln w="25400">
+            <a:solidFill>
+              <a:srgbClr val="D45D35"/>
+            </a:solidFill>
+          </a:ln>
+          <a:effectLst/>
+        </p:spPr>
+        <p:style>
+          <a:lnRef idx="1">
+            <a:schemeClr val="accent1"/>
+          </a:lnRef>
+          <a:fillRef idx="3">
+            <a:schemeClr val="accent1"/>
+          </a:fillRef>
+          <a:effectRef idx="2">
+            <a:schemeClr val="accent1"/>
+          </a:effectRef>
+          <a:fontRef idx="minor">
+            <a:schemeClr val="lt1"/>
+          </a:fontRef>
+        </p:style>
+        <p:txBody>
+          <a:bodyPr rtlCol="0" anchor="ctr" wrap="square" lIns="73152" rIns="73152"/>
+          <a:lstStyle/>
+          <a:p>
+            <a:pPr algn="ctr"/>
+            <a:r>
+              <a:rPr sz="1500" b="1">
+                <a:solidFill>
+                  <a:srgbClr val="DEE2E6"/>
+                </a:solidFill>
+              </a:rPr>
+              <a:t>Step the world</a:t>
+            </a:r>
+          </a:p>
+        </p:txBody>
+      </p:sp>
+      <p:cxnSp>
+        <p:nvCxnSpPr>
+          <p:cNvPr id="298" name="Connector 297"/>
+          <p:cNvCxnSpPr/>
+          <p:nvPr/>
+        </p:nvCxnSpPr>
+        <p:spPr>
+          <a:xfrm>
+            <a:off x="3127248" y="3131820"/>
+            <a:ext cx="237743" cy="0"/>
+          </a:xfrm>
+          <a:prstGeom prst="line">
+            <a:avLst/>
+          </a:prstGeom>
+          <a:ln w="25400">
+            <a:solidFill>
+              <a:srgbClr val="9AA3AB"/>
+            </a:solidFill>
+            <a:tailEnd type="triangle"/>
+          </a:ln>
+        </p:spPr>
+        <p:style>
+          <a:lnRef idx="2">
+            <a:schemeClr val="accent1"/>
+          </a:lnRef>
+          <a:fillRef idx="0">
+            <a:schemeClr val="accent1"/>
+          </a:fillRef>
+          <a:effectRef idx="1">
+            <a:schemeClr val="accent1"/>
+          </a:effectRef>
+          <a:fontRef idx="minor">
+            <a:schemeClr val="tx1"/>
+          </a:fontRef>
+        </p:style>
+      </p:cxnSp>
+      <p:sp>
+        <p:nvSpPr>
+          <p:cNvPr id="299" name="Rounded Rectangle 298"/>
+          <p:cNvSpPr/>
+          <p:nvPr/>
+        </p:nvSpPr>
+        <p:spPr>
+          <a:xfrm>
+            <a:off x="3383279" y="2834640"/>
+            <a:ext cx="2103120" cy="594360"/>
+          </a:xfrm>
+          <a:prstGeom prst="roundRect">
+            <a:avLst>
+              <a:gd name="adj" fmla="val 12000"/>
+            </a:avLst>
+          </a:prstGeom>
+          <a:solidFill>
+            <a:srgbClr val="2E3338"/>
+          </a:solidFill>
+          <a:ln>
+            <a:noFill/>
+          </a:ln>
+          <a:effectLst/>
+        </p:spPr>
+        <p:style>
+          <a:lnRef idx="1">
+            <a:schemeClr val="accent1"/>
+          </a:lnRef>
+          <a:fillRef idx="3">
+            <a:schemeClr val="accent1"/>
+          </a:fillRef>
+          <a:effectRef idx="2">
+            <a:schemeClr val="accent1"/>
+          </a:effectRef>
+          <a:fontRef idx="minor">
+            <a:schemeClr val="lt1"/>
+          </a:fontRef>
+        </p:style>
+        <p:txBody>
+          <a:bodyPr rtlCol="0" anchor="ctr" wrap="square" lIns="73152" rIns="73152"/>
+          <a:lstStyle/>
+          <a:p>
+            <a:pPr algn="ctr"/>
+            <a:r>
+              <a:rPr sz="1500" b="1">
+                <a:solidFill>
+                  <a:srgbClr val="DEE2E6"/>
+                </a:solidFill>
+              </a:rPr>
+              <a:t>Read the positions</a:t>
+            </a:r>
+          </a:p>
+        </p:txBody>
+      </p:sp>
+      <p:cxnSp>
+        <p:nvCxnSpPr>
+          <p:cNvPr id="300" name="Connector 299"/>
+          <p:cNvCxnSpPr/>
+          <p:nvPr/>
+        </p:nvCxnSpPr>
+        <p:spPr>
+          <a:xfrm>
+            <a:off x="5504688" y="3131820"/>
+            <a:ext cx="237744" cy="0"/>
+          </a:xfrm>
+          <a:prstGeom prst="line">
+            <a:avLst/>
+          </a:prstGeom>
+          <a:ln w="25400">
+            <a:solidFill>
+              <a:srgbClr val="9AA3AB"/>
+            </a:solidFill>
+            <a:tailEnd type="triangle"/>
+          </a:ln>
+        </p:spPr>
+        <p:style>
+          <a:lnRef idx="2">
+            <a:schemeClr val="accent1"/>
+          </a:lnRef>
+          <a:fillRef idx="0">
+            <a:schemeClr val="accent1"/>
+          </a:fillRef>
+          <a:effectRef idx="1">
+            <a:schemeClr val="accent1"/>
+          </a:effectRef>
+          <a:fontRef idx="minor">
+            <a:schemeClr val="tx1"/>
+          </a:fontRef>
+        </p:style>
+      </p:cxnSp>
+      <p:sp>
+        <p:nvSpPr>
+          <p:cNvPr id="301" name="Rounded Rectangle 300"/>
+          <p:cNvSpPr/>
+          <p:nvPr/>
+        </p:nvSpPr>
+        <p:spPr>
+          <a:xfrm>
+            <a:off x="5760719" y="2834640"/>
+            <a:ext cx="2103120" cy="594360"/>
+          </a:xfrm>
+          <a:prstGeom prst="roundRect">
+            <a:avLst>
+              <a:gd name="adj" fmla="val 12000"/>
+            </a:avLst>
+          </a:prstGeom>
+          <a:solidFill>
+            <a:srgbClr val="2E3338"/>
+          </a:solidFill>
+          <a:ln>
+            <a:noFill/>
+          </a:ln>
+          <a:effectLst/>
+        </p:spPr>
+        <p:style>
+          <a:lnRef idx="1">
+            <a:schemeClr val="accent1"/>
+          </a:lnRef>
+          <a:fillRef idx="3">
+            <a:schemeClr val="accent1"/>
+          </a:fillRef>
+          <a:effectRef idx="2">
+            <a:schemeClr val="accent1"/>
+          </a:effectRef>
+          <a:fontRef idx="minor">
+            <a:schemeClr val="lt1"/>
+          </a:fontRef>
+        </p:style>
+        <p:txBody>
+          <a:bodyPr rtlCol="0" anchor="ctr" wrap="square" lIns="73152" rIns="73152"/>
+          <a:lstStyle/>
+          <a:p>
+            <a:pPr algn="ctr"/>
+            <a:r>
+              <a:rPr sz="1500" b="1">
+                <a:solidFill>
+                  <a:srgbClr val="DEE2E6"/>
+                </a:solidFill>
+              </a:rPr>
+              <a:t>Draw the sprites there</a:t>
+            </a:r>
           </a:p>
         </p:txBody>
       </p:sp>
@@ -15178,7 +16549,7 @@
         <p:spPr>
           <a:xfrm>
             <a:off x="311700" y="885950"/>
-            <a:ext cx="8520600" cy="4023300"/>
+            <a:ext cx="8520600" cy="521208"/>
           </a:xfrm>
           <a:prstGeom prst="rect">
             <a:avLst/>
@@ -15202,94 +16573,335 @@
             </a:pPr>
             <a:r>
               <a:rPr lang="en"/>
-              <a:t>Box2D is tuned for objects of 0.1 to 10 metres</a:t>
+              <a:t>A 50-pixel block, taken as metres, is a 50-metre building: it falls in slow motion.</a:t>
             </a:r>
             <a:endParaRPr/>
           </a:p>
-          <a:p>
-            <a:pPr indent="-317500" lvl="1" marL="914400" rtl="0" algn="l">
-              <a:spcBef>
-                <a:spcPts val="0"/>
-              </a:spcBef>
-              <a:spcAft>
-                <a:spcPts val="0"/>
-              </a:spcAft>
-              <a:buSzPts val="1400"/>
-              <a:buChar char="○"/>
-            </a:pPr>
-            <a:r>
-              <a:rPr lang="en"/>
-              <a:t>A 50-pixel block would be a 50-metre block</a:t>
-            </a:r>
-            <a:endParaRPr/>
-          </a:p>
-          <a:p>
-            <a:pPr indent="-317500" lvl="1" marL="914400" rtl="0" algn="l">
-              <a:spcBef>
-                <a:spcPts val="0"/>
-              </a:spcBef>
-              <a:spcAft>
-                <a:spcPts val="0"/>
-              </a:spcAft>
-              <a:buSzPts val="1400"/>
-              <a:buChar char="○"/>
-            </a:pPr>
-            <a:r>
-              <a:rPr lang="en"/>
-              <a:t>It would fall as slowly as a building</a:t>
-            </a:r>
-            <a:endParaRPr/>
-          </a:p>
-          <a:p>
-            <a:pPr indent="-330200" lvl="0" marL="457200" rtl="0" algn="l">
-              <a:spcBef>
-                <a:spcPts val="0"/>
-              </a:spcBef>
-              <a:spcAft>
-                <a:spcPts val="0"/>
-              </a:spcAft>
-              <a:buSzPts val="1600"/>
-              <a:buChar char="●"/>
-            </a:pPr>
-            <a:r>
-              <a:rPr lang="en"/>
-              <a:t>Simulate in metres, draw in pixels: 50 pixels per metre</a:t>
-            </a:r>
-            <a:endParaRPr/>
-          </a:p>
-          <a:p>
-            <a:pPr indent="-330200" lvl="0" marL="457200" rtl="0" algn="l">
-              <a:spcBef>
-                <a:spcPts val="0"/>
-              </a:spcBef>
-              <a:spcAft>
-                <a:spcPts val="0"/>
-              </a:spcAft>
-              <a:buSzPts val="1600"/>
-              <a:buChar char="●"/>
-            </a:pPr>
-            <a:r>
-              <a:rPr lang="en"/>
-              <a:t>Box2D turns counter-clockwise, SpriteBatch clockwise</a:t>
-            </a:r>
-            <a:endParaRPr/>
-          </a:p>
-          <a:p>
-            <a:pPr indent="-330200" lvl="0" marL="457200" rtl="0" algn="l">
-              <a:spcBef>
-                <a:spcPts val="0"/>
-              </a:spcBef>
-              <a:spcAft>
-                <a:spcPts val="0"/>
-              </a:spcAft>
-              <a:buSzPts val="1600"/>
-              <a:buChar char="●"/>
-            </a:pPr>
-            <a:r>
-              <a:rPr lang="en"/>
-              <a:t>Forget one conversion: a body in the wrong place, or falling up</a:t>
-            </a:r>
-            <a:endParaRPr/>
+        </p:txBody>
+      </p:sp>
+      <p:sp>
+        <p:nvSpPr>
+          <p:cNvPr id="295" name="Rounded Rectangle 294"/>
+          <p:cNvSpPr/>
+          <p:nvPr/>
+        </p:nvSpPr>
+        <p:spPr>
+          <a:xfrm>
+            <a:off x="548640" y="1463040"/>
+            <a:ext cx="2743200" cy="914400"/>
+          </a:xfrm>
+          <a:prstGeom prst="roundRect">
+            <a:avLst>
+              <a:gd name="adj" fmla="val 12000"/>
+            </a:avLst>
+          </a:prstGeom>
+          <a:solidFill>
+            <a:srgbClr val="2E3338"/>
+          </a:solidFill>
+          <a:ln>
+            <a:noFill/>
+          </a:ln>
+          <a:effectLst/>
+        </p:spPr>
+        <p:style>
+          <a:lnRef idx="1">
+            <a:schemeClr val="accent1"/>
+          </a:lnRef>
+          <a:fillRef idx="3">
+            <a:schemeClr val="accent1"/>
+          </a:fillRef>
+          <a:effectRef idx="2">
+            <a:schemeClr val="accent1"/>
+          </a:effectRef>
+          <a:fontRef idx="minor">
+            <a:schemeClr val="lt1"/>
+          </a:fontRef>
+        </p:style>
+        <p:txBody>
+          <a:bodyPr rtlCol="0" anchor="ctr" wrap="square" lIns="73152" rIns="73152"/>
+          <a:lstStyle/>
+          <a:p>
+            <a:pPr algn="ctr"/>
+            <a:r>
+              <a:rPr sz="1600" b="1">
+                <a:solidFill>
+                  <a:srgbClr val="DEE2E6"/>
+                </a:solidFill>
+              </a:rPr>
+              <a:t>Our game</a:t>
+            </a:r>
+          </a:p>
+          <a:p>
+            <a:pPr algn="ctr"/>
+            <a:r>
+              <a:rPr sz="1400" b="0">
+                <a:solidFill>
+                  <a:srgbClr val="9AA3AB"/>
+                </a:solidFill>
+              </a:rPr>
+              <a:t>pixels, y down,</a:t>
+            </a:r>
+          </a:p>
+          <a:p>
+            <a:pPr algn="ctr"/>
+            <a:r>
+              <a:rPr sz="1400" b="0">
+                <a:solidFill>
+                  <a:srgbClr val="9AA3AB"/>
+                </a:solidFill>
+              </a:rPr>
+              <a:t>clockwise</a:t>
+            </a:r>
+          </a:p>
+        </p:txBody>
+      </p:sp>
+      <p:sp>
+        <p:nvSpPr>
+          <p:cNvPr id="296" name="Rounded Rectangle 295"/>
+          <p:cNvSpPr/>
+          <p:nvPr/>
+        </p:nvSpPr>
+        <p:spPr>
+          <a:xfrm>
+            <a:off x="5852160" y="1463040"/>
+            <a:ext cx="2743200" cy="914400"/>
+          </a:xfrm>
+          <a:prstGeom prst="roundRect">
+            <a:avLst>
+              <a:gd name="adj" fmla="val 12000"/>
+            </a:avLst>
+          </a:prstGeom>
+          <a:solidFill>
+            <a:srgbClr val="2E3338"/>
+          </a:solidFill>
+          <a:ln>
+            <a:noFill/>
+          </a:ln>
+          <a:effectLst/>
+        </p:spPr>
+        <p:style>
+          <a:lnRef idx="1">
+            <a:schemeClr val="accent1"/>
+          </a:lnRef>
+          <a:fillRef idx="3">
+            <a:schemeClr val="accent1"/>
+          </a:fillRef>
+          <a:effectRef idx="2">
+            <a:schemeClr val="accent1"/>
+          </a:effectRef>
+          <a:fontRef idx="minor">
+            <a:schemeClr val="lt1"/>
+          </a:fontRef>
+        </p:style>
+        <p:txBody>
+          <a:bodyPr rtlCol="0" anchor="ctr" wrap="square" lIns="73152" rIns="73152"/>
+          <a:lstStyle/>
+          <a:p>
+            <a:pPr algn="ctr"/>
+            <a:r>
+              <a:rPr sz="1600" b="1">
+                <a:solidFill>
+                  <a:srgbClr val="DEE2E6"/>
+                </a:solidFill>
+              </a:rPr>
+              <a:t>Box2D</a:t>
+            </a:r>
+          </a:p>
+          <a:p>
+            <a:pPr algn="ctr"/>
+            <a:r>
+              <a:rPr sz="1400" b="0">
+                <a:solidFill>
+                  <a:srgbClr val="9AA3AB"/>
+                </a:solidFill>
+              </a:rPr>
+              <a:t>metres, y up,</a:t>
+            </a:r>
+          </a:p>
+          <a:p>
+            <a:pPr algn="ctr"/>
+            <a:r>
+              <a:rPr sz="1400" b="0">
+                <a:solidFill>
+                  <a:srgbClr val="9AA3AB"/>
+                </a:solidFill>
+              </a:rPr>
+              <a:t>counter-clockwise</a:t>
+            </a:r>
+          </a:p>
+        </p:txBody>
+      </p:sp>
+      <p:cxnSp>
+        <p:nvCxnSpPr>
+          <p:cNvPr id="297" name="Connector 296"/>
+          <p:cNvCxnSpPr/>
+          <p:nvPr/>
+        </p:nvCxnSpPr>
+        <p:spPr>
+          <a:xfrm>
+            <a:off x="3337560" y="1783080"/>
+            <a:ext cx="2468880" cy="0"/>
+          </a:xfrm>
+          <a:prstGeom prst="line">
+            <a:avLst/>
+          </a:prstGeom>
+          <a:ln w="25400">
+            <a:solidFill>
+              <a:srgbClr val="D45D35"/>
+            </a:solidFill>
+            <a:tailEnd type="triangle"/>
+          </a:ln>
+        </p:spPr>
+        <p:style>
+          <a:lnRef idx="2">
+            <a:schemeClr val="accent1"/>
+          </a:lnRef>
+          <a:fillRef idx="0">
+            <a:schemeClr val="accent1"/>
+          </a:fillRef>
+          <a:effectRef idx="1">
+            <a:schemeClr val="accent1"/>
+          </a:effectRef>
+          <a:fontRef idx="minor">
+            <a:schemeClr val="tx1"/>
+          </a:fontRef>
+        </p:style>
+      </p:cxnSp>
+      <p:sp>
+        <p:nvSpPr>
+          <p:cNvPr id="298" name="TextBox 297"/>
+          <p:cNvSpPr txBox="1"/>
+          <p:nvPr/>
+        </p:nvSpPr>
+        <p:spPr>
+          <a:xfrm>
+            <a:off x="3154679" y="1490472"/>
+            <a:ext cx="2834639" cy="274320"/>
+          </a:xfrm>
+          <a:prstGeom prst="rect">
+            <a:avLst/>
+          </a:prstGeom>
+          <a:noFill/>
+        </p:spPr>
+        <p:txBody>
+          <a:bodyPr wrap="square">
+            <a:spAutoFit/>
+          </a:bodyPr>
+          <a:lstStyle/>
+          <a:p>
+            <a:pPr algn="ctr"/>
+            <a:r>
+              <a:rPr sz="1100" b="0" i="0">
+                <a:solidFill>
+                  <a:srgbClr val="9AA3AB"/>
+                </a:solidFill>
+              </a:rPr>
+              <a:t>÷ 50, flip y</a:t>
+            </a:r>
+          </a:p>
+        </p:txBody>
+      </p:sp>
+      <p:cxnSp>
+        <p:nvCxnSpPr>
+          <p:cNvPr id="299" name="Connector 298"/>
+          <p:cNvCxnSpPr/>
+          <p:nvPr/>
+        </p:nvCxnSpPr>
+        <p:spPr>
+          <a:xfrm flipH="1">
+            <a:off x="3337560" y="2103120"/>
+            <a:ext cx="2468880" cy="0"/>
+          </a:xfrm>
+          <a:prstGeom prst="line">
+            <a:avLst/>
+          </a:prstGeom>
+          <a:ln w="25400">
+            <a:solidFill>
+              <a:srgbClr val="D45D35"/>
+            </a:solidFill>
+            <a:tailEnd type="triangle"/>
+          </a:ln>
+        </p:spPr>
+        <p:style>
+          <a:lnRef idx="2">
+            <a:schemeClr val="accent1"/>
+          </a:lnRef>
+          <a:fillRef idx="0">
+            <a:schemeClr val="accent1"/>
+          </a:fillRef>
+          <a:effectRef idx="1">
+            <a:schemeClr val="accent1"/>
+          </a:effectRef>
+          <a:fontRef idx="minor">
+            <a:schemeClr val="tx1"/>
+          </a:fontRef>
+        </p:style>
+      </p:cxnSp>
+      <p:sp>
+        <p:nvSpPr>
+          <p:cNvPr id="300" name="TextBox 299"/>
+          <p:cNvSpPr txBox="1"/>
+          <p:nvPr/>
+        </p:nvSpPr>
+        <p:spPr>
+          <a:xfrm>
+            <a:off x="3337560" y="2148840"/>
+            <a:ext cx="2468880" cy="274320"/>
+          </a:xfrm>
+          <a:prstGeom prst="rect">
+            <a:avLst/>
+          </a:prstGeom>
+          <a:noFill/>
+        </p:spPr>
+        <p:txBody>
+          <a:bodyPr wrap="square">
+            <a:spAutoFit/>
+          </a:bodyPr>
+          <a:lstStyle/>
+          <a:p>
+            <a:pPr algn="ctr"/>
+            <a:r>
+              <a:rPr sz="1100" b="0" i="0">
+                <a:solidFill>
+                  <a:srgbClr val="9AA3AB"/>
+                </a:solidFill>
+              </a:rPr>
+              <a:t>× 50, flip y</a:t>
+            </a:r>
+          </a:p>
+        </p:txBody>
+      </p:sp>
+      <p:sp>
+        <p:nvSpPr>
+          <p:cNvPr id="301" name="TextBox 300"/>
+          <p:cNvSpPr txBox="1"/>
+          <p:nvPr/>
+        </p:nvSpPr>
+        <p:spPr>
+          <a:xfrm>
+            <a:off x="457200" y="2834640"/>
+            <a:ext cx="8229600" cy="731520"/>
+          </a:xfrm>
+          <a:prstGeom prst="rect">
+            <a:avLst/>
+          </a:prstGeom>
+          <a:noFill/>
+        </p:spPr>
+        <p:txBody>
+          <a:bodyPr wrap="square">
+            <a:spAutoFit/>
+          </a:bodyPr>
+          <a:lstStyle/>
+          <a:p>
+            <a:pPr algn="ctr"/>
+            <a:r>
+              <a:rPr sz="1700" b="1" i="0">
+                <a:solidFill>
+                  <a:srgbClr val="DEE2E6"/>
+                </a:solidFill>
+              </a:rPr>
+              <a:t>Forget one conversion. What do you see?</a:t>
+            </a:r>
           </a:p>
         </p:txBody>
       </p:sp>
@@ -15497,7 +17109,7 @@
         <p:spPr>
           <a:xfrm>
             <a:off x="311700" y="885950"/>
-            <a:ext cx="8520600" cy="4023300"/>
+            <a:ext cx="8520600" cy="521208"/>
           </a:xfrm>
           <a:prstGeom prst="rect">
             <a:avLst/>
@@ -15521,94 +17133,285 @@
             </a:pPr>
             <a:r>
               <a:rPr lang="en"/>
-              <a:t>Adapter: converts an interface into the one its users expect</a:t>
+              <a:t>Keep Box2D in one place: the rest of the game never sees a Box2D type.</a:t>
             </a:r>
             <a:endParaRPr/>
           </a:p>
-          <a:p>
-            <a:pPr indent="-317500" lvl="1" marL="914400" rtl="0" algn="l">
-              <a:spcBef>
-                <a:spcPts val="0"/>
-              </a:spcBef>
-              <a:spcAft>
-                <a:spcPts val="0"/>
-              </a:spcAft>
-              <a:buSzPts val="1400"/>
-              <a:buChar char="○"/>
-            </a:pPr>
-            <a:r>
-              <a:rPr lang="en"/>
-              <a:t>PhysicsBody wraps a Box2D body: pixels, clockwise, our types</a:t>
-            </a:r>
-            <a:endParaRPr/>
-          </a:p>
-          <a:p>
-            <a:pPr indent="-330200" lvl="0" marL="457200" rtl="0" algn="l">
-              <a:spcBef>
-                <a:spcPts val="0"/>
-              </a:spcBef>
-              <a:spcAft>
-                <a:spcPts val="0"/>
-              </a:spcAft>
-              <a:buSzPts val="1600"/>
-              <a:buChar char="●"/>
-            </a:pPr>
-            <a:r>
-              <a:rPr lang="en"/>
-              <a:t>Facade: one simple interface in front of a subsystem</a:t>
-            </a:r>
-            <a:endParaRPr/>
-          </a:p>
-          <a:p>
-            <a:pPr indent="-317500" lvl="1" marL="914400" rtl="0" algn="l">
-              <a:spcBef>
-                <a:spcPts val="0"/>
-              </a:spcBef>
-              <a:spcAft>
-                <a:spcPts val="0"/>
-              </a:spcAft>
-              <a:buSzPts val="1400"/>
-              <a:buChar char="○"/>
-            </a:pPr>
-            <a:r>
-              <a:rPr lang="en"/>
-              <a:t>Box2D has hundreds of functions; the game needs a handful</a:t>
-            </a:r>
-            <a:endParaRPr/>
-          </a:p>
-          <a:p>
-            <a:pPr indent="-317500" lvl="1" marL="914400" rtl="0" algn="l">
-              <a:spcBef>
-                <a:spcPts val="0"/>
-              </a:spcBef>
-              <a:spcAft>
-                <a:spcPts val="0"/>
-              </a:spcAft>
-              <a:buSzPts val="1400"/>
-              <a:buChar char="○"/>
-            </a:pPr>
-            <a:r>
-              <a:rPr lang="en"/>
-              <a:t>PhysicsWorld: create a box or a circle, step, destroy</a:t>
-            </a:r>
-            <a:endParaRPr/>
-          </a:p>
-          <a:p>
-            <a:pPr indent="-330200" lvl="0" marL="457200" rtl="0" algn="l">
-              <a:spcBef>
-                <a:spcPts val="0"/>
-              </a:spcBef>
-              <a:spcAft>
-                <a:spcPts val="0"/>
-              </a:spcAft>
-              <a:buSzPts val="1600"/>
-              <a:buChar char="●"/>
-            </a:pPr>
-            <a:r>
-              <a:rPr lang="en"/>
-              <a:t>The rest of the game never sees a Box2D type</a:t>
-            </a:r>
-            <a:endParaRPr/>
+        </p:txBody>
+      </p:sp>
+      <p:sp>
+        <p:nvSpPr>
+          <p:cNvPr id="295" name="Rounded Rectangle 294"/>
+          <p:cNvSpPr/>
+          <p:nvPr/>
+        </p:nvSpPr>
+        <p:spPr>
+          <a:xfrm>
+            <a:off x="548640" y="1371600"/>
+            <a:ext cx="8046720" cy="548640"/>
+          </a:xfrm>
+          <a:prstGeom prst="roundRect">
+            <a:avLst>
+              <a:gd name="adj" fmla="val 12000"/>
+            </a:avLst>
+          </a:prstGeom>
+          <a:solidFill>
+            <a:srgbClr val="2E3338"/>
+          </a:solidFill>
+          <a:ln>
+            <a:noFill/>
+          </a:ln>
+          <a:effectLst/>
+        </p:spPr>
+        <p:style>
+          <a:lnRef idx="1">
+            <a:schemeClr val="accent1"/>
+          </a:lnRef>
+          <a:fillRef idx="3">
+            <a:schemeClr val="accent1"/>
+          </a:fillRef>
+          <a:effectRef idx="2">
+            <a:schemeClr val="accent1"/>
+          </a:effectRef>
+          <a:fontRef idx="minor">
+            <a:schemeClr val="lt1"/>
+          </a:fontRef>
+        </p:style>
+        <p:txBody>
+          <a:bodyPr rtlCol="0" anchor="ctr" wrap="square" lIns="73152" rIns="73152"/>
+          <a:lstStyle/>
+          <a:p>
+            <a:pPr algn="ctr"/>
+            <a:r>
+              <a:rPr sz="1500" b="1">
+                <a:solidFill>
+                  <a:srgbClr val="DEE2E6"/>
+                </a:solidFill>
+              </a:rPr>
+              <a:t>The game: blocks, pigs, birds, levels</a:t>
+            </a:r>
+          </a:p>
+        </p:txBody>
+      </p:sp>
+      <p:sp>
+        <p:nvSpPr>
+          <p:cNvPr id="296" name="Rounded Rectangle 295"/>
+          <p:cNvSpPr/>
+          <p:nvPr/>
+        </p:nvSpPr>
+        <p:spPr>
+          <a:xfrm>
+            <a:off x="548640" y="2148840"/>
+            <a:ext cx="3886200" cy="822960"/>
+          </a:xfrm>
+          <a:prstGeom prst="roundRect">
+            <a:avLst>
+              <a:gd name="adj" fmla="val 12000"/>
+            </a:avLst>
+          </a:prstGeom>
+          <a:solidFill>
+            <a:srgbClr val="2E3338"/>
+          </a:solidFill>
+          <a:ln w="25400">
+            <a:solidFill>
+              <a:srgbClr val="D45D35"/>
+            </a:solidFill>
+          </a:ln>
+          <a:effectLst/>
+        </p:spPr>
+        <p:style>
+          <a:lnRef idx="1">
+            <a:schemeClr val="accent1"/>
+          </a:lnRef>
+          <a:fillRef idx="3">
+            <a:schemeClr val="accent1"/>
+          </a:fillRef>
+          <a:effectRef idx="2">
+            <a:schemeClr val="accent1"/>
+          </a:effectRef>
+          <a:fontRef idx="minor">
+            <a:schemeClr val="lt1"/>
+          </a:fontRef>
+        </p:style>
+        <p:txBody>
+          <a:bodyPr rtlCol="0" anchor="ctr" wrap="square" lIns="73152" rIns="73152"/>
+          <a:lstStyle/>
+          <a:p>
+            <a:pPr algn="ctr"/>
+            <a:r>
+              <a:rPr sz="1500" b="1">
+                <a:solidFill>
+                  <a:srgbClr val="DEE2E6"/>
+                </a:solidFill>
+              </a:rPr>
+              <a:t>PhysicsWorld: a Facade</a:t>
+            </a:r>
+          </a:p>
+          <a:p>
+            <a:pPr algn="ctr"/>
+            <a:r>
+              <a:rPr sz="1300" b="0">
+                <a:solidFill>
+                  <a:srgbClr val="9AA3AB"/>
+                </a:solidFill>
+              </a:rPr>
+              <a:t>a handful of calls: create, step, destroy</a:t>
+            </a:r>
+          </a:p>
+        </p:txBody>
+      </p:sp>
+      <p:sp>
+        <p:nvSpPr>
+          <p:cNvPr id="297" name="Rounded Rectangle 296"/>
+          <p:cNvSpPr/>
+          <p:nvPr/>
+        </p:nvSpPr>
+        <p:spPr>
+          <a:xfrm>
+            <a:off x="4709160" y="2148840"/>
+            <a:ext cx="3886200" cy="822960"/>
+          </a:xfrm>
+          <a:prstGeom prst="roundRect">
+            <a:avLst>
+              <a:gd name="adj" fmla="val 12000"/>
+            </a:avLst>
+          </a:prstGeom>
+          <a:solidFill>
+            <a:srgbClr val="2E3338"/>
+          </a:solidFill>
+          <a:ln w="25400">
+            <a:solidFill>
+              <a:srgbClr val="D45D35"/>
+            </a:solidFill>
+          </a:ln>
+          <a:effectLst/>
+        </p:spPr>
+        <p:style>
+          <a:lnRef idx="1">
+            <a:schemeClr val="accent1"/>
+          </a:lnRef>
+          <a:fillRef idx="3">
+            <a:schemeClr val="accent1"/>
+          </a:fillRef>
+          <a:effectRef idx="2">
+            <a:schemeClr val="accent1"/>
+          </a:effectRef>
+          <a:fontRef idx="minor">
+            <a:schemeClr val="lt1"/>
+          </a:fontRef>
+        </p:style>
+        <p:txBody>
+          <a:bodyPr rtlCol="0" anchor="ctr" wrap="square" lIns="73152" rIns="73152"/>
+          <a:lstStyle/>
+          <a:p>
+            <a:pPr algn="ctr"/>
+            <a:r>
+              <a:rPr sz="1500" b="1">
+                <a:solidFill>
+                  <a:srgbClr val="DEE2E6"/>
+                </a:solidFill>
+              </a:rPr>
+              <a:t>PhysicsBody: an Adapter</a:t>
+            </a:r>
+          </a:p>
+          <a:p>
+            <a:pPr algn="ctr"/>
+            <a:r>
+              <a:rPr sz="1300" b="0">
+                <a:solidFill>
+                  <a:srgbClr val="9AA3AB"/>
+                </a:solidFill>
+              </a:rPr>
+              <a:t>a body in pixels, turning like SpriteBatch</a:t>
+            </a:r>
+          </a:p>
+        </p:txBody>
+      </p:sp>
+      <p:sp>
+        <p:nvSpPr>
+          <p:cNvPr id="298" name="Rounded Rectangle 297"/>
+          <p:cNvSpPr/>
+          <p:nvPr/>
+        </p:nvSpPr>
+        <p:spPr>
+          <a:xfrm>
+            <a:off x="548640" y="3200400"/>
+            <a:ext cx="8046720" cy="548640"/>
+          </a:xfrm>
+          <a:prstGeom prst="roundRect">
+            <a:avLst>
+              <a:gd name="adj" fmla="val 12000"/>
+            </a:avLst>
+          </a:prstGeom>
+          <a:solidFill>
+            <a:srgbClr val="2E3338"/>
+          </a:solidFill>
+          <a:ln>
+            <a:noFill/>
+          </a:ln>
+          <a:effectLst/>
+        </p:spPr>
+        <p:style>
+          <a:lnRef idx="1">
+            <a:schemeClr val="accent1"/>
+          </a:lnRef>
+          <a:fillRef idx="3">
+            <a:schemeClr val="accent1"/>
+          </a:fillRef>
+          <a:effectRef idx="2">
+            <a:schemeClr val="accent1"/>
+          </a:effectRef>
+          <a:fontRef idx="minor">
+            <a:schemeClr val="lt1"/>
+          </a:fontRef>
+        </p:style>
+        <p:txBody>
+          <a:bodyPr rtlCol="0" anchor="ctr" wrap="square" lIns="73152" rIns="73152"/>
+          <a:lstStyle/>
+          <a:p>
+            <a:pPr algn="ctr"/>
+            <a:r>
+              <a:rPr sz="1500" b="1">
+                <a:solidFill>
+                  <a:srgbClr val="DEE2E6"/>
+                </a:solidFill>
+              </a:rPr>
+              <a:t>Box2D: hundreds of functions, metres, structs and IDs</a:t>
+            </a:r>
+          </a:p>
+        </p:txBody>
+      </p:sp>
+      <p:sp>
+        <p:nvSpPr>
+          <p:cNvPr id="299" name="TextBox 298"/>
+          <p:cNvSpPr txBox="1"/>
+          <p:nvPr/>
+        </p:nvSpPr>
+        <p:spPr>
+          <a:xfrm>
+            <a:off x="457200" y="3886200"/>
+            <a:ext cx="8229600" cy="731520"/>
+          </a:xfrm>
+          <a:prstGeom prst="rect">
+            <a:avLst/>
+          </a:prstGeom>
+          <a:noFill/>
+        </p:spPr>
+        <p:txBody>
+          <a:bodyPr wrap="square">
+            <a:spAutoFit/>
+          </a:bodyPr>
+          <a:lstStyle/>
+          <a:p>
+            <a:pPr algn="ctr"/>
+            <a:r>
+              <a:rPr sz="1500" b="1" i="0">
+                <a:solidFill>
+                  <a:srgbClr val="DEE2E6"/>
+                </a:solidFill>
+              </a:rPr>
+              <a:t>Swap Box2D for another library. Which files change?</a:t>
+            </a:r>
           </a:p>
         </p:txBody>
       </p:sp>

</xml_diff>

<commit_message>
Session 07: joints in the physics samples, on the site and in the deck; recorder keys 4 to 6
Co-Authored-By: Claude Opus 5.5 <noreply@anthropic.com>
Claude-Session: https://claude.ai/code/session_012sjsUQBbC7zon57rWHoo9d
</commit_message>
<xml_diff>
--- a/slides/07 Angry Birds.pptx
+++ b/slides/07 Angry Birds.pptx
@@ -2516,12 +2516,12 @@
           </a:p>
           <a:p>
             <a:r>
-              <a:t>5: sleeping, the pile turns blue; drop a box in to wake it.</a:t>
-            </a:r>
-          </a:p>
-          <a:p>
-            <a:r>
-              <a:t>Mention: the samples use the game’s facade, which got BodyType so they could make a kinematic platform.</a:t>
+              <a:t>5: sleeping, the pile turns blue; drop a box in to wake it. 6: joints: a hinged pendulum and chain, a rope that goes slack, a welded hammer.</a:t>
+            </a:r>
+          </a:p>
+          <a:p>
+            <a:r>
+              <a:t>Mention: the samples use the game’s facade, which got BodyType and joint methods so they could make a kinematic platform and joints.</a:t>
             </a:r>
           </a:p>
         </p:txBody>
@@ -2585,6 +2585,11 @@
           <a:p>
             <a:r>
               <a:t>The friction: about 0.23, not tan 26° (about 0.48). Box2D combines two frictions as the square root of their product, and the slope’s friction is 1: the square root of 0.23 is 0.48. A good reason to read what a library does.</a:t>
+            </a:r>
+          </a:p>
+          <a:p>
+            <a:r>
+              <a:t>The chain: Rope(lastLink, ball, ...) instead of Rope(hook, ball, ...), keeping the last link in a variable.</a:t>
             </a:r>
           </a:p>
         </p:txBody>
@@ -18398,7 +18403,7 @@
             </a:pPr>
             <a:r>
               <a:rPr lang="en"/>
-              <a:t>Body types, bounce, friction, density, sleeping</a:t>
+              <a:t>Body types, bounce, friction, density, sleeping, joints</a:t>
             </a:r>
             <a:endParaRPr/>
           </a:p>
@@ -18415,7 +18420,7 @@
             </a:pPr>
             <a:r>
               <a:rPr lang="en"/>
-              <a:t>Keys 1 to 5; click: a box, Space: a ball, R: again</a:t>
+              <a:t>Keys 1 to 6; click: a box, Space: a ball, R: again</a:t>
             </a:r>
             <a:endParaRPr/>
           </a:p>
@@ -18578,7 +18583,7 @@
             </a:pPr>
             <a:r>
               <a:rPr lang="en"/>
-              <a:t>Is it what you expected for 26 degrees?</a:t>
+              <a:t>Is it what you expected for 26 degrees? Then: hang the ball from the chain</a:t>
             </a:r>
             <a:endParaRPr/>
           </a:p>

</xml_diff>